<commit_message>
docs(ppt): align Slide 8 sequence diagram to Slide 7's 6 steps
Previous Slide 8 had 13 fine-grained arrows split across 5 lifelines
(Client / AP / chilli / Public RADIUS / DB). Audience-friendlier:
collapse to 6 numbered groups matching Slide 7's card layout exactly:

  ① DHCP             — 1 arrow
  ② HTTP 攔截        — 2 arrows (GET + 302 redirect)
  ③ Portal 登入      — 1 arrow
  ④ RADIUS Auth      — 2 arrows (Access-Request + SQL query)
  ⑤ Access-Accept    — 2 arrows (DB rows + Accept + WISPr)
  ⑥ 上網             — 1 arrow (ACL + leaky bucket + 302 google)

Reduced lifelines from 5 to 4 (dropped Wi-Fi AP since Slide 7 doesn't
distinguish L2 association). Each step group gets a colored ①-⑥ badge
on the left, matching the numbering used in Slide 7's card view.
Footer legend: solid line = Request, dashed = Response.

Co-Authored-By: Claude Sonnet 4.6 <noreply@anthropic.com>
</commit_message>
<xml_diff>
--- a/docs/CaptivePortal_FAE_Guide.pptx
+++ b/docs/CaptivePortal_FAE_Guide.pptx
@@ -19767,7 +19767,7 @@
                   <a:srgbClr val="E8722A"/>
                 </a:solidFill>
               </a:rPr>
-              <a:t>Client / chilli / RADIUS / DB 互動時序</a:t>
+              <a:t>對應上頁 6 步驟的時序視圖</a:t>
             </a:r>
           </a:p>
         </p:txBody>
@@ -19823,8 +19823,8 @@
         </p:nvSpPr>
         <p:spPr>
           <a:xfrm>
-            <a:off x="137160" y="1371600"/>
-            <a:ext cx="1554480" cy="384048"/>
+            <a:off x="548640" y="1371600"/>
+            <a:ext cx="1828800" cy="457200"/>
           </a:xfrm>
           <a:prstGeom prst="rect">
             <a:avLst/>
@@ -19866,23 +19866,23 @@
         </p:nvSpPr>
         <p:spPr>
           <a:xfrm>
-            <a:off x="155448" y="1408176"/>
-            <a:ext cx="1517904" cy="329184"/>
-          </a:xfrm>
-          <a:prstGeom prst="rect">
-            <a:avLst/>
-          </a:prstGeom>
-          <a:noFill/>
-        </p:spPr>
-        <p:txBody>
-          <a:bodyPr wrap="square">
-            <a:spAutoFit/>
-          </a:bodyPr>
-          <a:lstStyle/>
-          <a:p>
-            <a:pPr algn="ctr"/>
-            <a:r>
-              <a:rPr sz="1050" b="1" i="0">
+            <a:off x="566928" y="1426464"/>
+            <a:ext cx="1792224" cy="365760"/>
+          </a:xfrm>
+          <a:prstGeom prst="rect">
+            <a:avLst/>
+          </a:prstGeom>
+          <a:noFill/>
+        </p:spPr>
+        <p:txBody>
+          <a:bodyPr wrap="square">
+            <a:spAutoFit/>
+          </a:bodyPr>
+          <a:lstStyle/>
+          <a:p>
+            <a:pPr algn="ctr"/>
+            <a:r>
+              <a:rPr sz="1200" b="1" i="0">
                 <a:solidFill>
                   <a:srgbClr val="FFFFFF"/>
                 </a:solidFill>
@@ -19900,8 +19900,8 @@
         </p:nvCxnSpPr>
         <p:spPr>
           <a:xfrm>
-            <a:off x="914400" y="1783080"/>
-            <a:ext cx="0" cy="4709160"/>
+            <a:off x="1463040" y="1874520"/>
+            <a:ext cx="0" cy="4343400"/>
           </a:xfrm>
           <a:prstGeom prst="line">
             <a:avLst/>
@@ -19936,8 +19936,347 @@
         </p:nvSpPr>
         <p:spPr>
           <a:xfrm>
-            <a:off x="1965960" y="1371600"/>
-            <a:ext cx="1554480" cy="384048"/>
+            <a:off x="3840480" y="1371600"/>
+            <a:ext cx="1828800" cy="457200"/>
+          </a:xfrm>
+          <a:prstGeom prst="rect">
+            <a:avLst/>
+          </a:prstGeom>
+          <a:solidFill>
+            <a:srgbClr val="1A3C6E"/>
+          </a:solidFill>
+          <a:ln>
+            <a:noFill/>
+          </a:ln>
+        </p:spPr>
+        <p:style>
+          <a:lnRef idx="1">
+            <a:schemeClr val="accent1"/>
+          </a:lnRef>
+          <a:fillRef idx="3">
+            <a:schemeClr val="accent1"/>
+          </a:fillRef>
+          <a:effectRef idx="2">
+            <a:schemeClr val="accent1"/>
+          </a:effectRef>
+          <a:fontRef idx="minor">
+            <a:schemeClr val="lt1"/>
+          </a:fontRef>
+        </p:style>
+        <p:txBody>
+          <a:bodyPr rtlCol="0" anchor="ctr"/>
+          <a:lstStyle/>
+          <a:p>
+            <a:pPr algn="ctr"/>
+          </a:p>
+        </p:txBody>
+      </p:sp>
+      <p:sp>
+        <p:nvSpPr>
+          <p:cNvPr id="11" name="TextBox 10"/>
+          <p:cNvSpPr txBox="1"/>
+          <p:nvPr/>
+        </p:nvSpPr>
+        <p:spPr>
+          <a:xfrm>
+            <a:off x="3858768" y="1426464"/>
+            <a:ext cx="1792224" cy="365760"/>
+          </a:xfrm>
+          <a:prstGeom prst="rect">
+            <a:avLst/>
+          </a:prstGeom>
+          <a:noFill/>
+        </p:spPr>
+        <p:txBody>
+          <a:bodyPr wrap="square">
+            <a:spAutoFit/>
+          </a:bodyPr>
+          <a:lstStyle/>
+          <a:p>
+            <a:pPr algn="ctr"/>
+            <a:r>
+              <a:rPr sz="1200" b="1" i="0">
+                <a:solidFill>
+                  <a:srgbClr val="FFFFFF"/>
+                </a:solidFill>
+              </a:rPr>
+              <a:t>🖧  chilli</a:t>
+            </a:r>
+          </a:p>
+        </p:txBody>
+      </p:sp>
+      <p:cxnSp>
+        <p:nvCxnSpPr>
+          <p:cNvPr id="12" name="Connector 11"/>
+          <p:cNvCxnSpPr/>
+          <p:nvPr/>
+        </p:nvCxnSpPr>
+        <p:spPr>
+          <a:xfrm>
+            <a:off x="4754880" y="1874520"/>
+            <a:ext cx="0" cy="4343400"/>
+          </a:xfrm>
+          <a:prstGeom prst="line">
+            <a:avLst/>
+          </a:prstGeom>
+          <a:ln w="9525">
+            <a:solidFill>
+              <a:srgbClr val="666666"/>
+            </a:solidFill>
+            <a:prstDash val="dash"/>
+          </a:ln>
+        </p:spPr>
+        <p:style>
+          <a:lnRef idx="2">
+            <a:schemeClr val="accent1"/>
+          </a:lnRef>
+          <a:fillRef idx="0">
+            <a:schemeClr val="accent1"/>
+          </a:fillRef>
+          <a:effectRef idx="1">
+            <a:schemeClr val="accent1"/>
+          </a:effectRef>
+          <a:fontRef idx="minor">
+            <a:schemeClr val="tx1"/>
+          </a:fontRef>
+        </p:style>
+      </p:cxnSp>
+      <p:sp>
+        <p:nvSpPr>
+          <p:cNvPr id="13" name="Rectangle 12"/>
+          <p:cNvSpPr/>
+          <p:nvPr/>
+        </p:nvSpPr>
+        <p:spPr>
+          <a:xfrm>
+            <a:off x="7132320" y="1371600"/>
+            <a:ext cx="1828800" cy="457200"/>
+          </a:xfrm>
+          <a:prstGeom prst="rect">
+            <a:avLst/>
+          </a:prstGeom>
+          <a:solidFill>
+            <a:srgbClr val="E8722A"/>
+          </a:solidFill>
+          <a:ln>
+            <a:noFill/>
+          </a:ln>
+        </p:spPr>
+        <p:style>
+          <a:lnRef idx="1">
+            <a:schemeClr val="accent1"/>
+          </a:lnRef>
+          <a:fillRef idx="3">
+            <a:schemeClr val="accent1"/>
+          </a:fillRef>
+          <a:effectRef idx="2">
+            <a:schemeClr val="accent1"/>
+          </a:effectRef>
+          <a:fontRef idx="minor">
+            <a:schemeClr val="lt1"/>
+          </a:fontRef>
+        </p:style>
+        <p:txBody>
+          <a:bodyPr rtlCol="0" anchor="ctr"/>
+          <a:lstStyle/>
+          <a:p>
+            <a:pPr algn="ctr"/>
+          </a:p>
+        </p:txBody>
+      </p:sp>
+      <p:sp>
+        <p:nvSpPr>
+          <p:cNvPr id="14" name="TextBox 13"/>
+          <p:cNvSpPr txBox="1"/>
+          <p:nvPr/>
+        </p:nvSpPr>
+        <p:spPr>
+          <a:xfrm>
+            <a:off x="7150608" y="1426464"/>
+            <a:ext cx="1792224" cy="365760"/>
+          </a:xfrm>
+          <a:prstGeom prst="rect">
+            <a:avLst/>
+          </a:prstGeom>
+          <a:noFill/>
+        </p:spPr>
+        <p:txBody>
+          <a:bodyPr wrap="square">
+            <a:spAutoFit/>
+          </a:bodyPr>
+          <a:lstStyle/>
+          <a:p>
+            <a:pPr algn="ctr"/>
+            <a:r>
+              <a:rPr sz="1200" b="1" i="0">
+                <a:solidFill>
+                  <a:srgbClr val="FFFFFF"/>
+                </a:solidFill>
+              </a:rPr>
+              <a:t>🛡  FreeRADIUS</a:t>
+            </a:r>
+          </a:p>
+        </p:txBody>
+      </p:sp>
+      <p:cxnSp>
+        <p:nvCxnSpPr>
+          <p:cNvPr id="15" name="Connector 14"/>
+          <p:cNvCxnSpPr/>
+          <p:nvPr/>
+        </p:nvCxnSpPr>
+        <p:spPr>
+          <a:xfrm>
+            <a:off x="8046720" y="1874520"/>
+            <a:ext cx="0" cy="4343400"/>
+          </a:xfrm>
+          <a:prstGeom prst="line">
+            <a:avLst/>
+          </a:prstGeom>
+          <a:ln w="9525">
+            <a:solidFill>
+              <a:srgbClr val="666666"/>
+            </a:solidFill>
+            <a:prstDash val="dash"/>
+          </a:ln>
+        </p:spPr>
+        <p:style>
+          <a:lnRef idx="2">
+            <a:schemeClr val="accent1"/>
+          </a:lnRef>
+          <a:fillRef idx="0">
+            <a:schemeClr val="accent1"/>
+          </a:fillRef>
+          <a:effectRef idx="1">
+            <a:schemeClr val="accent1"/>
+          </a:effectRef>
+          <a:fontRef idx="minor">
+            <a:schemeClr val="tx1"/>
+          </a:fontRef>
+        </p:style>
+      </p:cxnSp>
+      <p:sp>
+        <p:nvSpPr>
+          <p:cNvPr id="16" name="Rectangle 15"/>
+          <p:cNvSpPr/>
+          <p:nvPr/>
+        </p:nvSpPr>
+        <p:spPr>
+          <a:xfrm>
+            <a:off x="9966960" y="1371600"/>
+            <a:ext cx="1828800" cy="457200"/>
+          </a:xfrm>
+          <a:prstGeom prst="rect">
+            <a:avLst/>
+          </a:prstGeom>
+          <a:solidFill>
+            <a:srgbClr val="6C3A8C"/>
+          </a:solidFill>
+          <a:ln>
+            <a:noFill/>
+          </a:ln>
+        </p:spPr>
+        <p:style>
+          <a:lnRef idx="1">
+            <a:schemeClr val="accent1"/>
+          </a:lnRef>
+          <a:fillRef idx="3">
+            <a:schemeClr val="accent1"/>
+          </a:fillRef>
+          <a:effectRef idx="2">
+            <a:schemeClr val="accent1"/>
+          </a:effectRef>
+          <a:fontRef idx="minor">
+            <a:schemeClr val="lt1"/>
+          </a:fontRef>
+        </p:style>
+        <p:txBody>
+          <a:bodyPr rtlCol="0" anchor="ctr"/>
+          <a:lstStyle/>
+          <a:p>
+            <a:pPr algn="ctr"/>
+          </a:p>
+        </p:txBody>
+      </p:sp>
+      <p:sp>
+        <p:nvSpPr>
+          <p:cNvPr id="17" name="TextBox 16"/>
+          <p:cNvSpPr txBox="1"/>
+          <p:nvPr/>
+        </p:nvSpPr>
+        <p:spPr>
+          <a:xfrm>
+            <a:off x="9985248" y="1426464"/>
+            <a:ext cx="1792224" cy="365760"/>
+          </a:xfrm>
+          <a:prstGeom prst="rect">
+            <a:avLst/>
+          </a:prstGeom>
+          <a:noFill/>
+        </p:spPr>
+        <p:txBody>
+          <a:bodyPr wrap="square">
+            <a:spAutoFit/>
+          </a:bodyPr>
+          <a:lstStyle/>
+          <a:p>
+            <a:pPr algn="ctr"/>
+            <a:r>
+              <a:rPr sz="1200" b="1" i="0">
+                <a:solidFill>
+                  <a:srgbClr val="FFFFFF"/>
+                </a:solidFill>
+              </a:rPr>
+              <a:t>🗄  MariaDB</a:t>
+            </a:r>
+          </a:p>
+        </p:txBody>
+      </p:sp>
+      <p:cxnSp>
+        <p:nvCxnSpPr>
+          <p:cNvPr id="18" name="Connector 17"/>
+          <p:cNvCxnSpPr/>
+          <p:nvPr/>
+        </p:nvCxnSpPr>
+        <p:spPr>
+          <a:xfrm>
+            <a:off x="10881360" y="1874520"/>
+            <a:ext cx="0" cy="4343400"/>
+          </a:xfrm>
+          <a:prstGeom prst="line">
+            <a:avLst/>
+          </a:prstGeom>
+          <a:ln w="9525">
+            <a:solidFill>
+              <a:srgbClr val="666666"/>
+            </a:solidFill>
+            <a:prstDash val="dash"/>
+          </a:ln>
+        </p:spPr>
+        <p:style>
+          <a:lnRef idx="2">
+            <a:schemeClr val="accent1"/>
+          </a:lnRef>
+          <a:fillRef idx="0">
+            <a:schemeClr val="accent1"/>
+          </a:fillRef>
+          <a:effectRef idx="1">
+            <a:schemeClr val="accent1"/>
+          </a:effectRef>
+          <a:fontRef idx="minor">
+            <a:schemeClr val="tx1"/>
+          </a:fontRef>
+        </p:style>
+      </p:cxnSp>
+      <p:sp>
+        <p:nvSpPr>
+          <p:cNvPr id="19" name="Rectangle 18"/>
+          <p:cNvSpPr/>
+          <p:nvPr/>
+        </p:nvSpPr>
+        <p:spPr>
+          <a:xfrm>
+            <a:off x="137160" y="1828800"/>
+            <a:ext cx="960120" cy="365760"/>
           </a:xfrm>
           <a:prstGeom prst="rect">
             <a:avLst/>
@@ -19973,14 +20312,14 @@
       </p:sp>
       <p:sp>
         <p:nvSpPr>
-          <p:cNvPr id="11" name="TextBox 10"/>
-          <p:cNvSpPr txBox="1"/>
-          <p:nvPr/>
-        </p:nvSpPr>
-        <p:spPr>
-          <a:xfrm>
-            <a:off x="1984248" y="1408176"/>
-            <a:ext cx="1517904" cy="329184"/>
+          <p:cNvPr id="20" name="TextBox 19"/>
+          <p:cNvSpPr txBox="1"/>
+          <p:nvPr/>
+        </p:nvSpPr>
+        <p:spPr>
+          <a:xfrm>
+            <a:off x="137160" y="1883664"/>
+            <a:ext cx="960120" cy="292608"/>
           </a:xfrm>
           <a:prstGeom prst="rect">
             <a:avLst/>
@@ -20000,30 +20339,30 @@
                   <a:srgbClr val="FFFFFF"/>
                 </a:solidFill>
               </a:rPr>
-              <a:t>📶  Wi-Fi AP</a:t>
+              <a:t>① DHCP</a:t>
             </a:r>
           </a:p>
         </p:txBody>
       </p:sp>
       <p:cxnSp>
         <p:nvCxnSpPr>
-          <p:cNvPr id="12" name="Connector 11"/>
+          <p:cNvPr id="21" name="Connector 20"/>
           <p:cNvCxnSpPr/>
           <p:nvPr/>
         </p:nvCxnSpPr>
         <p:spPr>
           <a:xfrm>
-            <a:off x="2743200" y="1783080"/>
-            <a:ext cx="0" cy="4709160"/>
+            <a:off x="1463040" y="1938528"/>
+            <a:ext cx="3291840" cy="0"/>
           </a:xfrm>
           <a:prstGeom prst="line">
             <a:avLst/>
           </a:prstGeom>
-          <a:ln w="9525">
+          <a:ln w="22860">
             <a:solidFill>
-              <a:srgbClr val="666666"/>
+              <a:srgbClr val="167A8C"/>
             </a:solidFill>
-            <a:prstDash val="dash"/>
+            <a:tailEnd type="triangle" w="med" len="med"/>
           </a:ln>
         </p:spPr>
         <p:style>
@@ -20043,14 +20382,266 @@
       </p:cxnSp>
       <p:sp>
         <p:nvSpPr>
-          <p:cNvPr id="13" name="Rectangle 12"/>
+          <p:cNvPr id="22" name="TextBox 21"/>
+          <p:cNvSpPr txBox="1"/>
+          <p:nvPr/>
+        </p:nvSpPr>
+        <p:spPr>
+          <a:xfrm>
+            <a:off x="914400" y="1645920"/>
+            <a:ext cx="4389120" cy="256032"/>
+          </a:xfrm>
+          <a:prstGeom prst="rect">
+            <a:avLst/>
+          </a:prstGeom>
+          <a:noFill/>
+        </p:spPr>
+        <p:txBody>
+          <a:bodyPr wrap="square">
+            <a:spAutoFit/>
+          </a:bodyPr>
+          <a:lstStyle/>
+          <a:p>
+            <a:pPr algn="ctr"/>
+            <a:r>
+              <a:rPr sz="950" b="0" i="0">
+                <a:solidFill>
+                  <a:srgbClr val="167A8C"/>
+                </a:solidFill>
+              </a:rPr>
+              <a:t>Discover / Offer / Request / ACK  →  192.168.182.x + DNS=192.168.182.1</a:t>
+            </a:r>
+          </a:p>
+        </p:txBody>
+      </p:sp>
+      <p:sp>
+        <p:nvSpPr>
+          <p:cNvPr id="23" name="Rectangle 22"/>
           <p:cNvSpPr/>
           <p:nvPr/>
         </p:nvSpPr>
         <p:spPr>
           <a:xfrm>
-            <a:off x="4160520" y="1371600"/>
-            <a:ext cx="1554480" cy="384048"/>
+            <a:off x="137160" y="2468880"/>
+            <a:ext cx="960120" cy="365760"/>
+          </a:xfrm>
+          <a:prstGeom prst="rect">
+            <a:avLst/>
+          </a:prstGeom>
+          <a:solidFill>
+            <a:srgbClr val="E8722A"/>
+          </a:solidFill>
+          <a:ln>
+            <a:noFill/>
+          </a:ln>
+        </p:spPr>
+        <p:style>
+          <a:lnRef idx="1">
+            <a:schemeClr val="accent1"/>
+          </a:lnRef>
+          <a:fillRef idx="3">
+            <a:schemeClr val="accent1"/>
+          </a:fillRef>
+          <a:effectRef idx="2">
+            <a:schemeClr val="accent1"/>
+          </a:effectRef>
+          <a:fontRef idx="minor">
+            <a:schemeClr val="lt1"/>
+          </a:fontRef>
+        </p:style>
+        <p:txBody>
+          <a:bodyPr rtlCol="0" anchor="ctr"/>
+          <a:lstStyle/>
+          <a:p>
+            <a:pPr algn="ctr"/>
+          </a:p>
+        </p:txBody>
+      </p:sp>
+      <p:sp>
+        <p:nvSpPr>
+          <p:cNvPr id="24" name="TextBox 23"/>
+          <p:cNvSpPr txBox="1"/>
+          <p:nvPr/>
+        </p:nvSpPr>
+        <p:spPr>
+          <a:xfrm>
+            <a:off x="137160" y="2523744"/>
+            <a:ext cx="960120" cy="292608"/>
+          </a:xfrm>
+          <a:prstGeom prst="rect">
+            <a:avLst/>
+          </a:prstGeom>
+          <a:noFill/>
+        </p:spPr>
+        <p:txBody>
+          <a:bodyPr wrap="square">
+            <a:spAutoFit/>
+          </a:bodyPr>
+          <a:lstStyle/>
+          <a:p>
+            <a:pPr algn="ctr"/>
+            <a:r>
+              <a:rPr sz="1050" b="1" i="0">
+                <a:solidFill>
+                  <a:srgbClr val="FFFFFF"/>
+                </a:solidFill>
+              </a:rPr>
+              <a:t>② HTTP 攔截</a:t>
+            </a:r>
+          </a:p>
+        </p:txBody>
+      </p:sp>
+      <p:cxnSp>
+        <p:nvCxnSpPr>
+          <p:cNvPr id="25" name="Connector 24"/>
+          <p:cNvCxnSpPr/>
+          <p:nvPr/>
+        </p:nvCxnSpPr>
+        <p:spPr>
+          <a:xfrm>
+            <a:off x="1463040" y="2578608"/>
+            <a:ext cx="3291840" cy="0"/>
+          </a:xfrm>
+          <a:prstGeom prst="line">
+            <a:avLst/>
+          </a:prstGeom>
+          <a:ln w="22860">
+            <a:solidFill>
+              <a:srgbClr val="E8722A"/>
+            </a:solidFill>
+            <a:tailEnd type="triangle" w="med" len="med"/>
+          </a:ln>
+        </p:spPr>
+        <p:style>
+          <a:lnRef idx="2">
+            <a:schemeClr val="accent1"/>
+          </a:lnRef>
+          <a:fillRef idx="0">
+            <a:schemeClr val="accent1"/>
+          </a:fillRef>
+          <a:effectRef idx="1">
+            <a:schemeClr val="accent1"/>
+          </a:effectRef>
+          <a:fontRef idx="minor">
+            <a:schemeClr val="tx1"/>
+          </a:fontRef>
+        </p:style>
+      </p:cxnSp>
+      <p:sp>
+        <p:nvSpPr>
+          <p:cNvPr id="26" name="TextBox 25"/>
+          <p:cNvSpPr txBox="1"/>
+          <p:nvPr/>
+        </p:nvSpPr>
+        <p:spPr>
+          <a:xfrm>
+            <a:off x="914400" y="2286000"/>
+            <a:ext cx="4389120" cy="256032"/>
+          </a:xfrm>
+          <a:prstGeom prst="rect">
+            <a:avLst/>
+          </a:prstGeom>
+          <a:noFill/>
+        </p:spPr>
+        <p:txBody>
+          <a:bodyPr wrap="square">
+            <a:spAutoFit/>
+          </a:bodyPr>
+          <a:lstStyle/>
+          <a:p>
+            <a:pPr algn="ctr"/>
+            <a:r>
+              <a:rPr sz="950" b="0" i="0">
+                <a:solidFill>
+                  <a:srgbClr val="E8722A"/>
+                </a:solidFill>
+              </a:rPr>
+              <a:t>HTTP GET  http://任意網站</a:t>
+            </a:r>
+          </a:p>
+        </p:txBody>
+      </p:sp>
+      <p:cxnSp>
+        <p:nvCxnSpPr>
+          <p:cNvPr id="27" name="Connector 26"/>
+          <p:cNvCxnSpPr/>
+          <p:nvPr/>
+        </p:nvCxnSpPr>
+        <p:spPr>
+          <a:xfrm flipH="1">
+            <a:off x="1463040" y="2962656"/>
+            <a:ext cx="3291840" cy="0"/>
+          </a:xfrm>
+          <a:prstGeom prst="line">
+            <a:avLst/>
+          </a:prstGeom>
+          <a:ln w="22860">
+            <a:solidFill>
+              <a:srgbClr val="E8722A"/>
+            </a:solidFill>
+            <a:prstDash val="dash"/>
+            <a:tailEnd type="triangle" w="med" len="med"/>
+          </a:ln>
+        </p:spPr>
+        <p:style>
+          <a:lnRef idx="2">
+            <a:schemeClr val="accent1"/>
+          </a:lnRef>
+          <a:fillRef idx="0">
+            <a:schemeClr val="accent1"/>
+          </a:fillRef>
+          <a:effectRef idx="1">
+            <a:schemeClr val="accent1"/>
+          </a:effectRef>
+          <a:fontRef idx="minor">
+            <a:schemeClr val="tx1"/>
+          </a:fontRef>
+        </p:style>
+      </p:cxnSp>
+      <p:sp>
+        <p:nvSpPr>
+          <p:cNvPr id="28" name="TextBox 27"/>
+          <p:cNvSpPr txBox="1"/>
+          <p:nvPr/>
+        </p:nvSpPr>
+        <p:spPr>
+          <a:xfrm>
+            <a:off x="914400" y="2670048"/>
+            <a:ext cx="4389120" cy="256032"/>
+          </a:xfrm>
+          <a:prstGeom prst="rect">
+            <a:avLst/>
+          </a:prstGeom>
+          <a:noFill/>
+        </p:spPr>
+        <p:txBody>
+          <a:bodyPr wrap="square">
+            <a:spAutoFit/>
+          </a:bodyPr>
+          <a:lstStyle/>
+          <a:p>
+            <a:pPr algn="ctr"/>
+            <a:r>
+              <a:rPr sz="950" b="0" i="0">
+                <a:solidFill>
+                  <a:srgbClr val="E8722A"/>
+                </a:solidFill>
+              </a:rPr>
+              <a:t>302 Redirect  →  /cgi-bin/hotspotlogin.cgi</a:t>
+            </a:r>
+          </a:p>
+        </p:txBody>
+      </p:sp>
+      <p:sp>
+        <p:nvSpPr>
+          <p:cNvPr id="29" name="Rectangle 28"/>
+          <p:cNvSpPr/>
+          <p:nvPr/>
+        </p:nvSpPr>
+        <p:spPr>
+          <a:xfrm>
+            <a:off x="137160" y="3520440"/>
+            <a:ext cx="960120" cy="365760"/>
           </a:xfrm>
           <a:prstGeom prst="rect">
             <a:avLst/>
@@ -20086,14 +20677,14 @@
       </p:sp>
       <p:sp>
         <p:nvSpPr>
-          <p:cNvPr id="14" name="TextBox 13"/>
-          <p:cNvSpPr txBox="1"/>
-          <p:nvPr/>
-        </p:nvSpPr>
-        <p:spPr>
-          <a:xfrm>
-            <a:off x="4178808" y="1408176"/>
-            <a:ext cx="1517904" cy="329184"/>
+          <p:cNvPr id="30" name="TextBox 29"/>
+          <p:cNvSpPr txBox="1"/>
+          <p:nvPr/>
+        </p:nvSpPr>
+        <p:spPr>
+          <a:xfrm>
+            <a:off x="137160" y="3575304"/>
+            <a:ext cx="960120" cy="292608"/>
           </a:xfrm>
           <a:prstGeom prst="rect">
             <a:avLst/>
@@ -20113,30 +20704,30 @@
                   <a:srgbClr val="FFFFFF"/>
                 </a:solidFill>
               </a:rPr>
-              <a:t>🖧  Moxa chilli</a:t>
+              <a:t>③ Portal 登入</a:t>
             </a:r>
           </a:p>
         </p:txBody>
       </p:sp>
       <p:cxnSp>
         <p:nvCxnSpPr>
-          <p:cNvPr id="15" name="Connector 14"/>
+          <p:cNvPr id="31" name="Connector 30"/>
           <p:cNvCxnSpPr/>
           <p:nvPr/>
         </p:nvCxnSpPr>
         <p:spPr>
           <a:xfrm>
-            <a:off x="4937760" y="1783080"/>
-            <a:ext cx="0" cy="4709160"/>
+            <a:off x="1463040" y="3630168"/>
+            <a:ext cx="3291840" cy="0"/>
           </a:xfrm>
           <a:prstGeom prst="line">
             <a:avLst/>
           </a:prstGeom>
-          <a:ln w="9525">
+          <a:ln w="22860">
             <a:solidFill>
-              <a:srgbClr val="666666"/>
+              <a:srgbClr val="1A3C6E"/>
             </a:solidFill>
-            <a:prstDash val="dash"/>
+            <a:tailEnd type="triangle" w="med" len="med"/>
           </a:ln>
         </p:spPr>
         <p:style>
@@ -20156,20 +20747,54 @@
       </p:cxnSp>
       <p:sp>
         <p:nvSpPr>
-          <p:cNvPr id="16" name="Rectangle 15"/>
+          <p:cNvPr id="32" name="TextBox 31"/>
+          <p:cNvSpPr txBox="1"/>
+          <p:nvPr/>
+        </p:nvSpPr>
+        <p:spPr>
+          <a:xfrm>
+            <a:off x="914400" y="3337560"/>
+            <a:ext cx="4389120" cy="256032"/>
+          </a:xfrm>
+          <a:prstGeom prst="rect">
+            <a:avLst/>
+          </a:prstGeom>
+          <a:noFill/>
+        </p:spPr>
+        <p:txBody>
+          <a:bodyPr wrap="square">
+            <a:spAutoFit/>
+          </a:bodyPr>
+          <a:lstStyle/>
+          <a:p>
+            <a:pPr algn="ctr"/>
+            <a:r>
+              <a:rPr sz="950" b="0" i="0">
+                <a:solidFill>
+                  <a:srgbClr val="1A3C6E"/>
+                </a:solidFill>
+              </a:rPr>
+              <a:t>POST 帳號/密碼  →  CGI 計算 CHAP-Response</a:t>
+            </a:r>
+          </a:p>
+        </p:txBody>
+      </p:sp>
+      <p:sp>
+        <p:nvSpPr>
+          <p:cNvPr id="33" name="Rectangle 32"/>
           <p:cNvSpPr/>
           <p:nvPr/>
         </p:nvSpPr>
         <p:spPr>
           <a:xfrm>
-            <a:off x="7086600" y="1371600"/>
-            <a:ext cx="1554480" cy="384048"/>
+            <a:off x="137160" y="4160520"/>
+            <a:ext cx="960120" cy="365760"/>
           </a:xfrm>
           <a:prstGeom prst="rect">
             <a:avLst/>
           </a:prstGeom>
           <a:solidFill>
-            <a:srgbClr val="E8722A"/>
+            <a:srgbClr val="167A8C"/>
           </a:solidFill>
           <a:ln>
             <a:noFill/>
@@ -20199,14 +20824,14 @@
       </p:sp>
       <p:sp>
         <p:nvSpPr>
-          <p:cNvPr id="17" name="TextBox 16"/>
-          <p:cNvSpPr txBox="1"/>
-          <p:nvPr/>
-        </p:nvSpPr>
-        <p:spPr>
-          <a:xfrm>
-            <a:off x="7104888" y="1408176"/>
-            <a:ext cx="1517904" cy="329184"/>
+          <p:cNvPr id="34" name="TextBox 33"/>
+          <p:cNvSpPr txBox="1"/>
+          <p:nvPr/>
+        </p:nvSpPr>
+        <p:spPr>
+          <a:xfrm>
+            <a:off x="137160" y="4215384"/>
+            <a:ext cx="960120" cy="292608"/>
           </a:xfrm>
           <a:prstGeom prst="rect">
             <a:avLst/>
@@ -20226,30 +20851,30 @@
                   <a:srgbClr val="FFFFFF"/>
                 </a:solidFill>
               </a:rPr>
-              <a:t>🛡  Public RADIUS</a:t>
+              <a:t>④ RADIUS Auth</a:t>
             </a:r>
           </a:p>
         </p:txBody>
       </p:sp>
       <p:cxnSp>
         <p:nvCxnSpPr>
-          <p:cNvPr id="18" name="Connector 17"/>
+          <p:cNvPr id="35" name="Connector 34"/>
           <p:cNvCxnSpPr/>
           <p:nvPr/>
         </p:nvCxnSpPr>
         <p:spPr>
           <a:xfrm>
-            <a:off x="7863840" y="1783080"/>
-            <a:ext cx="0" cy="4709160"/>
+            <a:off x="4754880" y="4270248"/>
+            <a:ext cx="3291840" cy="0"/>
           </a:xfrm>
           <a:prstGeom prst="line">
             <a:avLst/>
           </a:prstGeom>
-          <a:ln w="9525">
+          <a:ln w="22860">
             <a:solidFill>
-              <a:srgbClr val="666666"/>
+              <a:srgbClr val="167A8C"/>
             </a:solidFill>
-            <a:prstDash val="dash"/>
+            <a:tailEnd type="triangle" w="med" len="med"/>
           </a:ln>
         </p:spPr>
         <p:style>
@@ -20269,100 +20894,57 @@
       </p:cxnSp>
       <p:sp>
         <p:nvSpPr>
-          <p:cNvPr id="19" name="Rectangle 18"/>
-          <p:cNvSpPr/>
-          <p:nvPr/>
-        </p:nvSpPr>
-        <p:spPr>
-          <a:xfrm>
-            <a:off x="9829800" y="1371600"/>
-            <a:ext cx="1554480" cy="384048"/>
-          </a:xfrm>
-          <a:prstGeom prst="rect">
-            <a:avLst/>
-          </a:prstGeom>
-          <a:solidFill>
-            <a:srgbClr val="6C3A8C"/>
-          </a:solidFill>
-          <a:ln>
-            <a:noFill/>
-          </a:ln>
-        </p:spPr>
-        <p:style>
-          <a:lnRef idx="1">
-            <a:schemeClr val="accent1"/>
-          </a:lnRef>
-          <a:fillRef idx="3">
-            <a:schemeClr val="accent1"/>
-          </a:fillRef>
-          <a:effectRef idx="2">
-            <a:schemeClr val="accent1"/>
-          </a:effectRef>
-          <a:fontRef idx="minor">
-            <a:schemeClr val="lt1"/>
-          </a:fontRef>
-        </p:style>
-        <p:txBody>
-          <a:bodyPr rtlCol="0" anchor="ctr"/>
-          <a:lstStyle/>
-          <a:p>
-            <a:pPr algn="ctr"/>
-          </a:p>
-        </p:txBody>
-      </p:sp>
-      <p:sp>
-        <p:nvSpPr>
-          <p:cNvPr id="20" name="TextBox 19"/>
-          <p:cNvSpPr txBox="1"/>
-          <p:nvPr/>
-        </p:nvSpPr>
-        <p:spPr>
-          <a:xfrm>
-            <a:off x="9848088" y="1408176"/>
-            <a:ext cx="1517904" cy="329184"/>
-          </a:xfrm>
-          <a:prstGeom prst="rect">
-            <a:avLst/>
-          </a:prstGeom>
-          <a:noFill/>
-        </p:spPr>
-        <p:txBody>
-          <a:bodyPr wrap="square">
-            <a:spAutoFit/>
-          </a:bodyPr>
-          <a:lstStyle/>
-          <a:p>
-            <a:pPr algn="ctr"/>
-            <a:r>
-              <a:rPr sz="1050" b="1" i="0">
-                <a:solidFill>
-                  <a:srgbClr val="FFFFFF"/>
-                </a:solidFill>
-              </a:rPr>
-              <a:t>🗄  MariaDB</a:t>
+          <p:cNvPr id="36" name="TextBox 35"/>
+          <p:cNvSpPr txBox="1"/>
+          <p:nvPr/>
+        </p:nvSpPr>
+        <p:spPr>
+          <a:xfrm>
+            <a:off x="4206240" y="3977640"/>
+            <a:ext cx="4389120" cy="256032"/>
+          </a:xfrm>
+          <a:prstGeom prst="rect">
+            <a:avLst/>
+          </a:prstGeom>
+          <a:noFill/>
+        </p:spPr>
+        <p:txBody>
+          <a:bodyPr wrap="square">
+            <a:spAutoFit/>
+          </a:bodyPr>
+          <a:lstStyle/>
+          <a:p>
+            <a:pPr algn="ctr"/>
+            <a:r>
+              <a:rPr sz="950" b="0" i="0">
+                <a:solidFill>
+                  <a:srgbClr val="167A8C"/>
+                </a:solidFill>
+              </a:rPr>
+              <a:t>Access-Request (User-Name + CHAP-Password)</a:t>
             </a:r>
           </a:p>
         </p:txBody>
       </p:sp>
       <p:cxnSp>
         <p:nvCxnSpPr>
-          <p:cNvPr id="21" name="Connector 20"/>
+          <p:cNvPr id="37" name="Connector 36"/>
           <p:cNvCxnSpPr/>
           <p:nvPr/>
         </p:nvCxnSpPr>
         <p:spPr>
           <a:xfrm>
-            <a:off x="10607040" y="1783080"/>
-            <a:ext cx="0" cy="4709160"/>
+            <a:off x="8046720" y="4654296"/>
+            <a:ext cx="2834640" cy="0"/>
           </a:xfrm>
           <a:prstGeom prst="line">
             <a:avLst/>
           </a:prstGeom>
-          <a:ln w="9525">
+          <a:ln w="22860">
             <a:solidFill>
-              <a:srgbClr val="666666"/>
+              <a:srgbClr val="167A8C"/>
             </a:solidFill>
-            <a:prstDash val="dash"/>
+            <a:tailEnd type="triangle" w="med" len="med"/>
           </a:ln>
         </p:spPr>
         <p:style>
@@ -20382,20 +20964,54 @@
       </p:cxnSp>
       <p:sp>
         <p:nvSpPr>
-          <p:cNvPr id="22" name="Rectangle 21"/>
+          <p:cNvPr id="38" name="TextBox 37"/>
+          <p:cNvSpPr txBox="1"/>
+          <p:nvPr/>
+        </p:nvSpPr>
+        <p:spPr>
+          <a:xfrm>
+            <a:off x="7269480" y="4361688"/>
+            <a:ext cx="4389120" cy="256032"/>
+          </a:xfrm>
+          <a:prstGeom prst="rect">
+            <a:avLst/>
+          </a:prstGeom>
+          <a:noFill/>
+        </p:spPr>
+        <p:txBody>
+          <a:bodyPr wrap="square">
+            <a:spAutoFit/>
+          </a:bodyPr>
+          <a:lstStyle/>
+          <a:p>
+            <a:pPr algn="ctr"/>
+            <a:r>
+              <a:rPr sz="950" b="0" i="0">
+                <a:solidFill>
+                  <a:srgbClr val="167A8C"/>
+                </a:solidFill>
+              </a:rPr>
+              <a:t>SELECT radcheck WHERE username=</a:t>
+            </a:r>
+          </a:p>
+        </p:txBody>
+      </p:sp>
+      <p:sp>
+        <p:nvSpPr>
+          <p:cNvPr id="39" name="Rectangle 38"/>
           <p:cNvSpPr/>
           <p:nvPr/>
         </p:nvSpPr>
         <p:spPr>
           <a:xfrm>
-            <a:off x="548640" y="1755647"/>
-            <a:ext cx="292608" cy="237744"/>
+            <a:off x="137160" y="5212079"/>
+            <a:ext cx="960120" cy="365760"/>
           </a:xfrm>
           <a:prstGeom prst="rect">
             <a:avLst/>
           </a:prstGeom>
           <a:solidFill>
-            <a:srgbClr val="167A8C"/>
+            <a:srgbClr val="27AE60"/>
           </a:solidFill>
           <a:ln>
             <a:noFill/>
@@ -20425,56 +21041,57 @@
       </p:sp>
       <p:sp>
         <p:nvSpPr>
-          <p:cNvPr id="23" name="TextBox 22"/>
-          <p:cNvSpPr txBox="1"/>
-          <p:nvPr/>
-        </p:nvSpPr>
-        <p:spPr>
-          <a:xfrm>
-            <a:off x="548640" y="1755647"/>
-            <a:ext cx="292608" cy="237744"/>
-          </a:xfrm>
-          <a:prstGeom prst="rect">
-            <a:avLst/>
-          </a:prstGeom>
-          <a:noFill/>
-        </p:spPr>
-        <p:txBody>
-          <a:bodyPr wrap="square">
-            <a:spAutoFit/>
-          </a:bodyPr>
-          <a:lstStyle/>
-          <a:p>
-            <a:pPr algn="ctr"/>
-            <a:r>
-              <a:rPr sz="1000" b="1" i="0">
+          <p:cNvPr id="40" name="TextBox 39"/>
+          <p:cNvSpPr txBox="1"/>
+          <p:nvPr/>
+        </p:nvSpPr>
+        <p:spPr>
+          <a:xfrm>
+            <a:off x="137160" y="5266943"/>
+            <a:ext cx="960120" cy="292608"/>
+          </a:xfrm>
+          <a:prstGeom prst="rect">
+            <a:avLst/>
+          </a:prstGeom>
+          <a:noFill/>
+        </p:spPr>
+        <p:txBody>
+          <a:bodyPr wrap="square">
+            <a:spAutoFit/>
+          </a:bodyPr>
+          <a:lstStyle/>
+          <a:p>
+            <a:pPr algn="ctr"/>
+            <a:r>
+              <a:rPr sz="1050" b="1" i="0">
                 <a:solidFill>
                   <a:srgbClr val="FFFFFF"/>
                 </a:solidFill>
               </a:rPr>
-              <a:t>1</a:t>
+              <a:t>⑤ Access-Accept</a:t>
             </a:r>
           </a:p>
         </p:txBody>
       </p:sp>
       <p:cxnSp>
         <p:nvCxnSpPr>
-          <p:cNvPr id="24" name="Connector 23"/>
+          <p:cNvPr id="41" name="Connector 40"/>
           <p:cNvCxnSpPr/>
           <p:nvPr/>
         </p:nvCxnSpPr>
         <p:spPr>
-          <a:xfrm>
-            <a:off x="914400" y="1874519"/>
-            <a:ext cx="1828800" cy="0"/>
+          <a:xfrm flipH="1">
+            <a:off x="8046720" y="5321807"/>
+            <a:ext cx="2834640" cy="0"/>
           </a:xfrm>
           <a:prstGeom prst="line">
             <a:avLst/>
           </a:prstGeom>
-          <a:ln w="20320">
+          <a:ln w="22860">
             <a:solidFill>
-              <a:srgbClr val="167A8C"/>
+              <a:srgbClr val="27AE60"/>
             </a:solidFill>
+            <a:prstDash val="dash"/>
             <a:tailEnd type="triangle" w="med" len="med"/>
           </a:ln>
         </p:spPr>
@@ -20495,14 +21112,14 @@
       </p:cxnSp>
       <p:sp>
         <p:nvSpPr>
-          <p:cNvPr id="25" name="TextBox 24"/>
-          <p:cNvSpPr txBox="1"/>
-          <p:nvPr/>
-        </p:nvSpPr>
-        <p:spPr>
-          <a:xfrm>
-            <a:off x="-182880" y="1581911"/>
-            <a:ext cx="4023360" cy="256032"/>
+          <p:cNvPr id="42" name="TextBox 41"/>
+          <p:cNvSpPr txBox="1"/>
+          <p:nvPr/>
+        </p:nvSpPr>
+        <p:spPr>
+          <a:xfrm>
+            <a:off x="7269480" y="5029199"/>
+            <a:ext cx="4389120" cy="256032"/>
           </a:xfrm>
           <a:prstGeom prst="rect">
             <a:avLst/>
@@ -20519,109 +21136,33 @@
             <a:r>
               <a:rPr sz="950" b="0" i="0">
                 <a:solidFill>
-                  <a:srgbClr val="167A8C"/>
-                </a:solidFill>
-              </a:rPr>
-              <a:t>Wi-Fi Association</a:t>
-            </a:r>
-          </a:p>
-        </p:txBody>
-      </p:sp>
-      <p:sp>
-        <p:nvSpPr>
-          <p:cNvPr id="26" name="Rectangle 25"/>
-          <p:cNvSpPr/>
-          <p:nvPr/>
-        </p:nvSpPr>
-        <p:spPr>
-          <a:xfrm>
-            <a:off x="548640" y="2139696"/>
-            <a:ext cx="292608" cy="237744"/>
-          </a:xfrm>
-          <a:prstGeom prst="rect">
-            <a:avLst/>
-          </a:prstGeom>
-          <a:solidFill>
-            <a:srgbClr val="167A8C"/>
-          </a:solidFill>
-          <a:ln>
-            <a:noFill/>
-          </a:ln>
-        </p:spPr>
-        <p:style>
-          <a:lnRef idx="1">
-            <a:schemeClr val="accent1"/>
-          </a:lnRef>
-          <a:fillRef idx="3">
-            <a:schemeClr val="accent1"/>
-          </a:fillRef>
-          <a:effectRef idx="2">
-            <a:schemeClr val="accent1"/>
-          </a:effectRef>
-          <a:fontRef idx="minor">
-            <a:schemeClr val="lt1"/>
-          </a:fontRef>
-        </p:style>
-        <p:txBody>
-          <a:bodyPr rtlCol="0" anchor="ctr"/>
-          <a:lstStyle/>
-          <a:p>
-            <a:pPr algn="ctr"/>
-          </a:p>
-        </p:txBody>
-      </p:sp>
-      <p:sp>
-        <p:nvSpPr>
-          <p:cNvPr id="27" name="TextBox 26"/>
-          <p:cNvSpPr txBox="1"/>
-          <p:nvPr/>
-        </p:nvSpPr>
-        <p:spPr>
-          <a:xfrm>
-            <a:off x="548640" y="2139696"/>
-            <a:ext cx="292608" cy="237744"/>
-          </a:xfrm>
-          <a:prstGeom prst="rect">
-            <a:avLst/>
-          </a:prstGeom>
-          <a:noFill/>
-        </p:spPr>
-        <p:txBody>
-          <a:bodyPr wrap="square">
-            <a:spAutoFit/>
-          </a:bodyPr>
-          <a:lstStyle/>
-          <a:p>
-            <a:pPr algn="ctr"/>
-            <a:r>
-              <a:rPr sz="1000" b="1" i="0">
-                <a:solidFill>
-                  <a:srgbClr val="FFFFFF"/>
-                </a:solidFill>
-              </a:rPr>
-              <a:t>2</a:t>
+                  <a:srgbClr val="27AE60"/>
+                </a:solidFill>
+              </a:rPr>
+              <a:t>rows (Cleartext-Password + WISPr attrs)</a:t>
             </a:r>
           </a:p>
         </p:txBody>
       </p:sp>
       <p:cxnSp>
         <p:nvCxnSpPr>
-          <p:cNvPr id="28" name="Connector 27"/>
+          <p:cNvPr id="43" name="Connector 42"/>
           <p:cNvCxnSpPr/>
           <p:nvPr/>
         </p:nvCxnSpPr>
         <p:spPr>
-          <a:xfrm>
-            <a:off x="914400" y="2258568"/>
-            <a:ext cx="4023360" cy="0"/>
+          <a:xfrm flipH="1">
+            <a:off x="4754880" y="5705855"/>
+            <a:ext cx="3291840" cy="0"/>
           </a:xfrm>
           <a:prstGeom prst="line">
             <a:avLst/>
           </a:prstGeom>
-          <a:ln w="20320">
+          <a:ln w="22860">
             <a:solidFill>
-              <a:srgbClr val="167A8C"/>
+              <a:srgbClr val="27AE60"/>
             </a:solidFill>
+            <a:prstDash val="dash"/>
             <a:tailEnd type="triangle" w="med" len="med"/>
           </a:ln>
         </p:spPr>
@@ -20642,14 +21183,14 @@
       </p:cxnSp>
       <p:sp>
         <p:nvSpPr>
-          <p:cNvPr id="29" name="TextBox 28"/>
-          <p:cNvSpPr txBox="1"/>
-          <p:nvPr/>
-        </p:nvSpPr>
-        <p:spPr>
-          <a:xfrm>
-            <a:off x="914400" y="1965960"/>
-            <a:ext cx="4023360" cy="256032"/>
+          <p:cNvPr id="44" name="TextBox 43"/>
+          <p:cNvSpPr txBox="1"/>
+          <p:nvPr/>
+        </p:nvSpPr>
+        <p:spPr>
+          <a:xfrm>
+            <a:off x="4206240" y="5413247"/>
+            <a:ext cx="4389120" cy="256032"/>
           </a:xfrm>
           <a:prstGeom prst="rect">
             <a:avLst/>
@@ -20666,30 +21207,30 @@
             <a:r>
               <a:rPr sz="950" b="0" i="0">
                 <a:solidFill>
-                  <a:srgbClr val="167A8C"/>
-                </a:solidFill>
-              </a:rPr>
-              <a:t>DHCP Discover/Offer/Req/ACK (192.168.182.x)</a:t>
-            </a:r>
-          </a:p>
-        </p:txBody>
-      </p:sp>
-      <p:sp>
-        <p:nvSpPr>
-          <p:cNvPr id="30" name="Rectangle 29"/>
+                  <a:srgbClr val="27AE60"/>
+                </a:solidFill>
+              </a:rPr>
+              <a:t>Access-Accept  +  Session-Timeout / WISPr-Bandwidth</a:t>
+            </a:r>
+          </a:p>
+        </p:txBody>
+      </p:sp>
+      <p:sp>
+        <p:nvSpPr>
+          <p:cNvPr id="45" name="Rectangle 44"/>
           <p:cNvSpPr/>
           <p:nvPr/>
         </p:nvSpPr>
         <p:spPr>
           <a:xfrm>
-            <a:off x="548640" y="2523743"/>
-            <a:ext cx="292608" cy="237744"/>
+            <a:off x="137160" y="6263640"/>
+            <a:ext cx="960120" cy="365760"/>
           </a:xfrm>
           <a:prstGeom prst="rect">
             <a:avLst/>
           </a:prstGeom>
           <a:solidFill>
-            <a:srgbClr val="1A3C6E"/>
+            <a:srgbClr val="27AE60"/>
           </a:solidFill>
           <a:ln>
             <a:noFill/>
@@ -20719,56 +21260,57 @@
       </p:sp>
       <p:sp>
         <p:nvSpPr>
-          <p:cNvPr id="31" name="TextBox 30"/>
-          <p:cNvSpPr txBox="1"/>
-          <p:nvPr/>
-        </p:nvSpPr>
-        <p:spPr>
-          <a:xfrm>
-            <a:off x="548640" y="2523743"/>
-            <a:ext cx="292608" cy="237744"/>
-          </a:xfrm>
-          <a:prstGeom prst="rect">
-            <a:avLst/>
-          </a:prstGeom>
-          <a:noFill/>
-        </p:spPr>
-        <p:txBody>
-          <a:bodyPr wrap="square">
-            <a:spAutoFit/>
-          </a:bodyPr>
-          <a:lstStyle/>
-          <a:p>
-            <a:pPr algn="ctr"/>
-            <a:r>
-              <a:rPr sz="1000" b="1" i="0">
+          <p:cNvPr id="46" name="TextBox 45"/>
+          <p:cNvSpPr txBox="1"/>
+          <p:nvPr/>
+        </p:nvSpPr>
+        <p:spPr>
+          <a:xfrm>
+            <a:off x="137160" y="6318504"/>
+            <a:ext cx="960120" cy="292608"/>
+          </a:xfrm>
+          <a:prstGeom prst="rect">
+            <a:avLst/>
+          </a:prstGeom>
+          <a:noFill/>
+        </p:spPr>
+        <p:txBody>
+          <a:bodyPr wrap="square">
+            <a:spAutoFit/>
+          </a:bodyPr>
+          <a:lstStyle/>
+          <a:p>
+            <a:pPr algn="ctr"/>
+            <a:r>
+              <a:rPr sz="1050" b="1" i="0">
                 <a:solidFill>
                   <a:srgbClr val="FFFFFF"/>
                 </a:solidFill>
               </a:rPr>
-              <a:t>3</a:t>
+              <a:t>⑥ 上網</a:t>
             </a:r>
           </a:p>
         </p:txBody>
       </p:sp>
       <p:cxnSp>
         <p:nvCxnSpPr>
-          <p:cNvPr id="32" name="Connector 31"/>
+          <p:cNvPr id="47" name="Connector 46"/>
           <p:cNvCxnSpPr/>
           <p:nvPr/>
         </p:nvCxnSpPr>
         <p:spPr>
-          <a:xfrm>
-            <a:off x="914400" y="2642615"/>
-            <a:ext cx="4023360" cy="0"/>
+          <a:xfrm flipH="1">
+            <a:off x="1463040" y="6373368"/>
+            <a:ext cx="3291840" cy="0"/>
           </a:xfrm>
           <a:prstGeom prst="line">
             <a:avLst/>
           </a:prstGeom>
-          <a:ln w="20320">
+          <a:ln w="22860">
             <a:solidFill>
-              <a:srgbClr val="1A3C6E"/>
+              <a:srgbClr val="27AE60"/>
             </a:solidFill>
+            <a:prstDash val="dash"/>
             <a:tailEnd type="triangle" w="med" len="med"/>
           </a:ln>
         </p:spPr>
@@ -20789,14 +21331,14 @@
       </p:cxnSp>
       <p:sp>
         <p:nvSpPr>
-          <p:cNvPr id="33" name="TextBox 32"/>
-          <p:cNvSpPr txBox="1"/>
-          <p:nvPr/>
-        </p:nvSpPr>
-        <p:spPr>
-          <a:xfrm>
-            <a:off x="914400" y="2350007"/>
-            <a:ext cx="4023360" cy="256032"/>
+          <p:cNvPr id="48" name="TextBox 47"/>
+          <p:cNvSpPr txBox="1"/>
+          <p:nvPr/>
+        </p:nvSpPr>
+        <p:spPr>
+          <a:xfrm>
+            <a:off x="914400" y="6080760"/>
+            <a:ext cx="4389120" cy="256032"/>
           </a:xfrm>
           <a:prstGeom prst="rect">
             <a:avLst/>
@@ -20813,1492 +21355,17 @@
             <a:r>
               <a:rPr sz="950" b="0" i="0">
                 <a:solidFill>
-                  <a:srgbClr val="1A3C6E"/>
-                </a:solidFill>
-              </a:rPr>
-              <a:t>HTTP GET example.com</a:t>
-            </a:r>
-          </a:p>
-        </p:txBody>
-      </p:sp>
-      <p:sp>
-        <p:nvSpPr>
-          <p:cNvPr id="34" name="Rectangle 33"/>
-          <p:cNvSpPr/>
-          <p:nvPr/>
-        </p:nvSpPr>
-        <p:spPr>
-          <a:xfrm>
-            <a:off x="548640" y="2907791"/>
-            <a:ext cx="292608" cy="237744"/>
-          </a:xfrm>
-          <a:prstGeom prst="rect">
-            <a:avLst/>
-          </a:prstGeom>
-          <a:solidFill>
-            <a:srgbClr val="E8722A"/>
-          </a:solidFill>
-          <a:ln>
-            <a:noFill/>
-          </a:ln>
-        </p:spPr>
-        <p:style>
-          <a:lnRef idx="1">
-            <a:schemeClr val="accent1"/>
-          </a:lnRef>
-          <a:fillRef idx="3">
-            <a:schemeClr val="accent1"/>
-          </a:fillRef>
-          <a:effectRef idx="2">
-            <a:schemeClr val="accent1"/>
-          </a:effectRef>
-          <a:fontRef idx="minor">
-            <a:schemeClr val="lt1"/>
-          </a:fontRef>
-        </p:style>
-        <p:txBody>
-          <a:bodyPr rtlCol="0" anchor="ctr"/>
-          <a:lstStyle/>
-          <a:p>
-            <a:pPr algn="ctr"/>
-          </a:p>
-        </p:txBody>
-      </p:sp>
-      <p:sp>
-        <p:nvSpPr>
-          <p:cNvPr id="35" name="TextBox 34"/>
-          <p:cNvSpPr txBox="1"/>
-          <p:nvPr/>
-        </p:nvSpPr>
-        <p:spPr>
-          <a:xfrm>
-            <a:off x="548640" y="2907791"/>
-            <a:ext cx="292608" cy="237744"/>
-          </a:xfrm>
-          <a:prstGeom prst="rect">
-            <a:avLst/>
-          </a:prstGeom>
-          <a:noFill/>
-        </p:spPr>
-        <p:txBody>
-          <a:bodyPr wrap="square">
-            <a:spAutoFit/>
-          </a:bodyPr>
-          <a:lstStyle/>
-          <a:p>
-            <a:pPr algn="ctr"/>
-            <a:r>
-              <a:rPr sz="1000" b="1" i="0">
-                <a:solidFill>
-                  <a:srgbClr val="FFFFFF"/>
-                </a:solidFill>
-              </a:rPr>
-              <a:t>4</a:t>
-            </a:r>
-          </a:p>
-        </p:txBody>
-      </p:sp>
-      <p:cxnSp>
-        <p:nvCxnSpPr>
-          <p:cNvPr id="36" name="Connector 35"/>
-          <p:cNvCxnSpPr/>
-          <p:nvPr/>
-        </p:nvCxnSpPr>
-        <p:spPr>
-          <a:xfrm flipH="1">
-            <a:off x="914400" y="3026663"/>
-            <a:ext cx="4023360" cy="0"/>
-          </a:xfrm>
-          <a:prstGeom prst="line">
-            <a:avLst/>
-          </a:prstGeom>
-          <a:ln w="20320">
-            <a:solidFill>
-              <a:srgbClr val="E8722A"/>
-            </a:solidFill>
-            <a:prstDash val="dash"/>
-            <a:tailEnd type="triangle" w="med" len="med"/>
-          </a:ln>
-        </p:spPr>
-        <p:style>
-          <a:lnRef idx="2">
-            <a:schemeClr val="accent1"/>
-          </a:lnRef>
-          <a:fillRef idx="0">
-            <a:schemeClr val="accent1"/>
-          </a:fillRef>
-          <a:effectRef idx="1">
-            <a:schemeClr val="accent1"/>
-          </a:effectRef>
-          <a:fontRef idx="minor">
-            <a:schemeClr val="tx1"/>
-          </a:fontRef>
-        </p:style>
-      </p:cxnSp>
-      <p:sp>
-        <p:nvSpPr>
-          <p:cNvPr id="37" name="TextBox 36"/>
-          <p:cNvSpPr txBox="1"/>
-          <p:nvPr/>
-        </p:nvSpPr>
-        <p:spPr>
-          <a:xfrm>
-            <a:off x="914400" y="2734055"/>
-            <a:ext cx="4023360" cy="256032"/>
-          </a:xfrm>
-          <a:prstGeom prst="rect">
-            <a:avLst/>
-          </a:prstGeom>
-          <a:noFill/>
-        </p:spPr>
-        <p:txBody>
-          <a:bodyPr wrap="square">
-            <a:spAutoFit/>
-          </a:bodyPr>
-          <a:lstStyle/>
-          <a:p>
-            <a:pPr algn="ctr"/>
-            <a:r>
-              <a:rPr sz="950" b="0" i="0">
-                <a:solidFill>
-                  <a:srgbClr val="E8722A"/>
-                </a:solidFill>
-              </a:rPr>
-              <a:t>302 Redirect → portal CGI</a:t>
-            </a:r>
-          </a:p>
-        </p:txBody>
-      </p:sp>
-      <p:sp>
-        <p:nvSpPr>
-          <p:cNvPr id="38" name="Rectangle 37"/>
-          <p:cNvSpPr/>
-          <p:nvPr/>
-        </p:nvSpPr>
-        <p:spPr>
-          <a:xfrm>
-            <a:off x="548640" y="3291839"/>
-            <a:ext cx="292608" cy="237744"/>
-          </a:xfrm>
-          <a:prstGeom prst="rect">
-            <a:avLst/>
-          </a:prstGeom>
-          <a:solidFill>
-            <a:srgbClr val="1A3C6E"/>
-          </a:solidFill>
-          <a:ln>
-            <a:noFill/>
-          </a:ln>
-        </p:spPr>
-        <p:style>
-          <a:lnRef idx="1">
-            <a:schemeClr val="accent1"/>
-          </a:lnRef>
-          <a:fillRef idx="3">
-            <a:schemeClr val="accent1"/>
-          </a:fillRef>
-          <a:effectRef idx="2">
-            <a:schemeClr val="accent1"/>
-          </a:effectRef>
-          <a:fontRef idx="minor">
-            <a:schemeClr val="lt1"/>
-          </a:fontRef>
-        </p:style>
-        <p:txBody>
-          <a:bodyPr rtlCol="0" anchor="ctr"/>
-          <a:lstStyle/>
-          <a:p>
-            <a:pPr algn="ctr"/>
-          </a:p>
-        </p:txBody>
-      </p:sp>
-      <p:sp>
-        <p:nvSpPr>
-          <p:cNvPr id="39" name="TextBox 38"/>
-          <p:cNvSpPr txBox="1"/>
-          <p:nvPr/>
-        </p:nvSpPr>
-        <p:spPr>
-          <a:xfrm>
-            <a:off x="548640" y="3291839"/>
-            <a:ext cx="292608" cy="237744"/>
-          </a:xfrm>
-          <a:prstGeom prst="rect">
-            <a:avLst/>
-          </a:prstGeom>
-          <a:noFill/>
-        </p:spPr>
-        <p:txBody>
-          <a:bodyPr wrap="square">
-            <a:spAutoFit/>
-          </a:bodyPr>
-          <a:lstStyle/>
-          <a:p>
-            <a:pPr algn="ctr"/>
-            <a:r>
-              <a:rPr sz="1000" b="1" i="0">
-                <a:solidFill>
-                  <a:srgbClr val="FFFFFF"/>
-                </a:solidFill>
-              </a:rPr>
-              <a:t>5</a:t>
-            </a:r>
-          </a:p>
-        </p:txBody>
-      </p:sp>
-      <p:cxnSp>
-        <p:nvCxnSpPr>
-          <p:cNvPr id="40" name="Connector 39"/>
-          <p:cNvCxnSpPr/>
-          <p:nvPr/>
-        </p:nvCxnSpPr>
-        <p:spPr>
-          <a:xfrm>
-            <a:off x="914400" y="3410711"/>
-            <a:ext cx="4023360" cy="0"/>
-          </a:xfrm>
-          <a:prstGeom prst="line">
-            <a:avLst/>
-          </a:prstGeom>
-          <a:ln w="20320">
-            <a:solidFill>
-              <a:srgbClr val="1A3C6E"/>
-            </a:solidFill>
-            <a:tailEnd type="triangle" w="med" len="med"/>
-          </a:ln>
-        </p:spPr>
-        <p:style>
-          <a:lnRef idx="2">
-            <a:schemeClr val="accent1"/>
-          </a:lnRef>
-          <a:fillRef idx="0">
-            <a:schemeClr val="accent1"/>
-          </a:fillRef>
-          <a:effectRef idx="1">
-            <a:schemeClr val="accent1"/>
-          </a:effectRef>
-          <a:fontRef idx="minor">
-            <a:schemeClr val="tx1"/>
-          </a:fontRef>
-        </p:style>
-      </p:cxnSp>
-      <p:sp>
-        <p:nvSpPr>
-          <p:cNvPr id="41" name="TextBox 40"/>
-          <p:cNvSpPr txBox="1"/>
-          <p:nvPr/>
-        </p:nvSpPr>
-        <p:spPr>
-          <a:xfrm>
-            <a:off x="914400" y="3118103"/>
-            <a:ext cx="4023360" cy="256032"/>
-          </a:xfrm>
-          <a:prstGeom prst="rect">
-            <a:avLst/>
-          </a:prstGeom>
-          <a:noFill/>
-        </p:spPr>
-        <p:txBody>
-          <a:bodyPr wrap="square">
-            <a:spAutoFit/>
-          </a:bodyPr>
-          <a:lstStyle/>
-          <a:p>
-            <a:pPr algn="ctr"/>
-            <a:r>
-              <a:rPr sz="950" b="0" i="0">
-                <a:solidFill>
-                  <a:srgbClr val="1A3C6E"/>
-                </a:solidFill>
-              </a:rPr>
-              <a:t>GET /cgi-bin/hotspotlogin.cgi (portal)</a:t>
-            </a:r>
-          </a:p>
-        </p:txBody>
-      </p:sp>
-      <p:sp>
-        <p:nvSpPr>
-          <p:cNvPr id="42" name="Rectangle 41"/>
-          <p:cNvSpPr/>
-          <p:nvPr/>
-        </p:nvSpPr>
-        <p:spPr>
-          <a:xfrm>
-            <a:off x="548640" y="3675888"/>
-            <a:ext cx="292608" cy="237744"/>
-          </a:xfrm>
-          <a:prstGeom prst="rect">
-            <a:avLst/>
-          </a:prstGeom>
-          <a:solidFill>
-            <a:srgbClr val="1A3C6E"/>
-          </a:solidFill>
-          <a:ln>
-            <a:noFill/>
-          </a:ln>
-        </p:spPr>
-        <p:style>
-          <a:lnRef idx="1">
-            <a:schemeClr val="accent1"/>
-          </a:lnRef>
-          <a:fillRef idx="3">
-            <a:schemeClr val="accent1"/>
-          </a:fillRef>
-          <a:effectRef idx="2">
-            <a:schemeClr val="accent1"/>
-          </a:effectRef>
-          <a:fontRef idx="minor">
-            <a:schemeClr val="lt1"/>
-          </a:fontRef>
-        </p:style>
-        <p:txBody>
-          <a:bodyPr rtlCol="0" anchor="ctr"/>
-          <a:lstStyle/>
-          <a:p>
-            <a:pPr algn="ctr"/>
-          </a:p>
-        </p:txBody>
-      </p:sp>
-      <p:sp>
-        <p:nvSpPr>
-          <p:cNvPr id="43" name="TextBox 42"/>
-          <p:cNvSpPr txBox="1"/>
-          <p:nvPr/>
-        </p:nvSpPr>
-        <p:spPr>
-          <a:xfrm>
-            <a:off x="548640" y="3675888"/>
-            <a:ext cx="292608" cy="237744"/>
-          </a:xfrm>
-          <a:prstGeom prst="rect">
-            <a:avLst/>
-          </a:prstGeom>
-          <a:noFill/>
-        </p:spPr>
-        <p:txBody>
-          <a:bodyPr wrap="square">
-            <a:spAutoFit/>
-          </a:bodyPr>
-          <a:lstStyle/>
-          <a:p>
-            <a:pPr algn="ctr"/>
-            <a:r>
-              <a:rPr sz="1000" b="1" i="0">
-                <a:solidFill>
-                  <a:srgbClr val="FFFFFF"/>
-                </a:solidFill>
-              </a:rPr>
-              <a:t>6</a:t>
-            </a:r>
-          </a:p>
-        </p:txBody>
-      </p:sp>
-      <p:cxnSp>
-        <p:nvCxnSpPr>
-          <p:cNvPr id="44" name="Connector 43"/>
-          <p:cNvCxnSpPr/>
-          <p:nvPr/>
-        </p:nvCxnSpPr>
-        <p:spPr>
-          <a:xfrm flipH="1">
-            <a:off x="914400" y="3794760"/>
-            <a:ext cx="4023360" cy="0"/>
-          </a:xfrm>
-          <a:prstGeom prst="line">
-            <a:avLst/>
-          </a:prstGeom>
-          <a:ln w="20320">
-            <a:solidFill>
-              <a:srgbClr val="1A3C6E"/>
-            </a:solidFill>
-            <a:prstDash val="dash"/>
-            <a:tailEnd type="triangle" w="med" len="med"/>
-          </a:ln>
-        </p:spPr>
-        <p:style>
-          <a:lnRef idx="2">
-            <a:schemeClr val="accent1"/>
-          </a:lnRef>
-          <a:fillRef idx="0">
-            <a:schemeClr val="accent1"/>
-          </a:fillRef>
-          <a:effectRef idx="1">
-            <a:schemeClr val="accent1"/>
-          </a:effectRef>
-          <a:fontRef idx="minor">
-            <a:schemeClr val="tx1"/>
-          </a:fontRef>
-        </p:style>
-      </p:cxnSp>
-      <p:sp>
-        <p:nvSpPr>
-          <p:cNvPr id="45" name="TextBox 44"/>
-          <p:cNvSpPr txBox="1"/>
-          <p:nvPr/>
-        </p:nvSpPr>
-        <p:spPr>
-          <a:xfrm>
-            <a:off x="914400" y="3502152"/>
-            <a:ext cx="4023360" cy="256032"/>
-          </a:xfrm>
-          <a:prstGeom prst="rect">
-            <a:avLst/>
-          </a:prstGeom>
-          <a:noFill/>
-        </p:spPr>
-        <p:txBody>
-          <a:bodyPr wrap="square">
-            <a:spAutoFit/>
-          </a:bodyPr>
-          <a:lstStyle/>
-          <a:p>
-            <a:pPr algn="ctr"/>
-            <a:r>
-              <a:rPr sz="950" b="0" i="0">
-                <a:solidFill>
-                  <a:srgbClr val="1A3C6E"/>
-                </a:solidFill>
-              </a:rPr>
-              <a:t>HTML 登入表單</a:t>
-            </a:r>
-          </a:p>
-        </p:txBody>
-      </p:sp>
-      <p:sp>
-        <p:nvSpPr>
-          <p:cNvPr id="46" name="Rectangle 45"/>
-          <p:cNvSpPr/>
-          <p:nvPr/>
-        </p:nvSpPr>
-        <p:spPr>
-          <a:xfrm>
-            <a:off x="548640" y="4059936"/>
-            <a:ext cx="292608" cy="237744"/>
-          </a:xfrm>
-          <a:prstGeom prst="rect">
-            <a:avLst/>
-          </a:prstGeom>
-          <a:solidFill>
-            <a:srgbClr val="1A3C6E"/>
-          </a:solidFill>
-          <a:ln>
-            <a:noFill/>
-          </a:ln>
-        </p:spPr>
-        <p:style>
-          <a:lnRef idx="1">
-            <a:schemeClr val="accent1"/>
-          </a:lnRef>
-          <a:fillRef idx="3">
-            <a:schemeClr val="accent1"/>
-          </a:fillRef>
-          <a:effectRef idx="2">
-            <a:schemeClr val="accent1"/>
-          </a:effectRef>
-          <a:fontRef idx="minor">
-            <a:schemeClr val="lt1"/>
-          </a:fontRef>
-        </p:style>
-        <p:txBody>
-          <a:bodyPr rtlCol="0" anchor="ctr"/>
-          <a:lstStyle/>
-          <a:p>
-            <a:pPr algn="ctr"/>
-          </a:p>
-        </p:txBody>
-      </p:sp>
-      <p:sp>
-        <p:nvSpPr>
-          <p:cNvPr id="47" name="TextBox 46"/>
-          <p:cNvSpPr txBox="1"/>
-          <p:nvPr/>
-        </p:nvSpPr>
-        <p:spPr>
-          <a:xfrm>
-            <a:off x="548640" y="4059936"/>
-            <a:ext cx="292608" cy="237744"/>
-          </a:xfrm>
-          <a:prstGeom prst="rect">
-            <a:avLst/>
-          </a:prstGeom>
-          <a:noFill/>
-        </p:spPr>
-        <p:txBody>
-          <a:bodyPr wrap="square">
-            <a:spAutoFit/>
-          </a:bodyPr>
-          <a:lstStyle/>
-          <a:p>
-            <a:pPr algn="ctr"/>
-            <a:r>
-              <a:rPr sz="1000" b="1" i="0">
-                <a:solidFill>
-                  <a:srgbClr val="FFFFFF"/>
-                </a:solidFill>
-              </a:rPr>
-              <a:t>7</a:t>
-            </a:r>
-          </a:p>
-        </p:txBody>
-      </p:sp>
-      <p:cxnSp>
-        <p:nvCxnSpPr>
-          <p:cNvPr id="48" name="Connector 47"/>
-          <p:cNvCxnSpPr/>
-          <p:nvPr/>
-        </p:nvCxnSpPr>
-        <p:spPr>
-          <a:xfrm>
-            <a:off x="914400" y="4178808"/>
-            <a:ext cx="4023360" cy="0"/>
-          </a:xfrm>
-          <a:prstGeom prst="line">
-            <a:avLst/>
-          </a:prstGeom>
-          <a:ln w="20320">
-            <a:solidFill>
-              <a:srgbClr val="1A3C6E"/>
-            </a:solidFill>
-            <a:tailEnd type="triangle" w="med" len="med"/>
-          </a:ln>
-        </p:spPr>
-        <p:style>
-          <a:lnRef idx="2">
-            <a:schemeClr val="accent1"/>
-          </a:lnRef>
-          <a:fillRef idx="0">
-            <a:schemeClr val="accent1"/>
-          </a:fillRef>
-          <a:effectRef idx="1">
-            <a:schemeClr val="accent1"/>
-          </a:effectRef>
-          <a:fontRef idx="minor">
-            <a:schemeClr val="tx1"/>
-          </a:fontRef>
-        </p:style>
-      </p:cxnSp>
-      <p:sp>
-        <p:nvSpPr>
-          <p:cNvPr id="49" name="TextBox 48"/>
-          <p:cNvSpPr txBox="1"/>
-          <p:nvPr/>
-        </p:nvSpPr>
-        <p:spPr>
-          <a:xfrm>
-            <a:off x="914400" y="3886200"/>
-            <a:ext cx="4023360" cy="256032"/>
-          </a:xfrm>
-          <a:prstGeom prst="rect">
-            <a:avLst/>
-          </a:prstGeom>
-          <a:noFill/>
-        </p:spPr>
-        <p:txBody>
-          <a:bodyPr wrap="square">
-            <a:spAutoFit/>
-          </a:bodyPr>
-          <a:lstStyle/>
-          <a:p>
-            <a:pPr algn="ctr"/>
-            <a:r>
-              <a:rPr sz="950" b="0" i="0">
-                <a:solidFill>
-                  <a:srgbClr val="1A3C6E"/>
-                </a:solidFill>
-              </a:rPr>
-              <a:t>POST 帳號/密碼 → CGI 計算 CHAP-Response</a:t>
-            </a:r>
-          </a:p>
-        </p:txBody>
-      </p:sp>
-      <p:sp>
-        <p:nvSpPr>
-          <p:cNvPr id="50" name="Rectangle 49"/>
-          <p:cNvSpPr/>
-          <p:nvPr/>
-        </p:nvSpPr>
-        <p:spPr>
-          <a:xfrm>
-            <a:off x="4572000" y="4443984"/>
-            <a:ext cx="292608" cy="237744"/>
-          </a:xfrm>
-          <a:prstGeom prst="rect">
-            <a:avLst/>
-          </a:prstGeom>
-          <a:solidFill>
-            <a:srgbClr val="E8722A"/>
-          </a:solidFill>
-          <a:ln>
-            <a:noFill/>
-          </a:ln>
-        </p:spPr>
-        <p:style>
-          <a:lnRef idx="1">
-            <a:schemeClr val="accent1"/>
-          </a:lnRef>
-          <a:fillRef idx="3">
-            <a:schemeClr val="accent1"/>
-          </a:fillRef>
-          <a:effectRef idx="2">
-            <a:schemeClr val="accent1"/>
-          </a:effectRef>
-          <a:fontRef idx="minor">
-            <a:schemeClr val="lt1"/>
-          </a:fontRef>
-        </p:style>
-        <p:txBody>
-          <a:bodyPr rtlCol="0" anchor="ctr"/>
-          <a:lstStyle/>
-          <a:p>
-            <a:pPr algn="ctr"/>
-          </a:p>
-        </p:txBody>
-      </p:sp>
-      <p:sp>
-        <p:nvSpPr>
-          <p:cNvPr id="51" name="TextBox 50"/>
-          <p:cNvSpPr txBox="1"/>
-          <p:nvPr/>
-        </p:nvSpPr>
-        <p:spPr>
-          <a:xfrm>
-            <a:off x="4572000" y="4443984"/>
-            <a:ext cx="292608" cy="237744"/>
-          </a:xfrm>
-          <a:prstGeom prst="rect">
-            <a:avLst/>
-          </a:prstGeom>
-          <a:noFill/>
-        </p:spPr>
-        <p:txBody>
-          <a:bodyPr wrap="square">
-            <a:spAutoFit/>
-          </a:bodyPr>
-          <a:lstStyle/>
-          <a:p>
-            <a:pPr algn="ctr"/>
-            <a:r>
-              <a:rPr sz="1000" b="1" i="0">
-                <a:solidFill>
-                  <a:srgbClr val="FFFFFF"/>
-                </a:solidFill>
-              </a:rPr>
-              <a:t>8</a:t>
-            </a:r>
-          </a:p>
-        </p:txBody>
-      </p:sp>
-      <p:cxnSp>
-        <p:nvCxnSpPr>
-          <p:cNvPr id="52" name="Connector 51"/>
-          <p:cNvCxnSpPr/>
-          <p:nvPr/>
-        </p:nvCxnSpPr>
-        <p:spPr>
-          <a:xfrm>
-            <a:off x="4937760" y="4562856"/>
-            <a:ext cx="2926080" cy="0"/>
-          </a:xfrm>
-          <a:prstGeom prst="line">
-            <a:avLst/>
-          </a:prstGeom>
-          <a:ln w="20320">
-            <a:solidFill>
-              <a:srgbClr val="E8722A"/>
-            </a:solidFill>
-            <a:tailEnd type="triangle" w="med" len="med"/>
-          </a:ln>
-        </p:spPr>
-        <p:style>
-          <a:lnRef idx="2">
-            <a:schemeClr val="accent1"/>
-          </a:lnRef>
-          <a:fillRef idx="0">
-            <a:schemeClr val="accent1"/>
-          </a:fillRef>
-          <a:effectRef idx="1">
-            <a:schemeClr val="accent1"/>
-          </a:effectRef>
-          <a:fontRef idx="minor">
-            <a:schemeClr val="tx1"/>
-          </a:fontRef>
-        </p:style>
-      </p:cxnSp>
-      <p:sp>
-        <p:nvSpPr>
-          <p:cNvPr id="53" name="TextBox 52"/>
-          <p:cNvSpPr txBox="1"/>
-          <p:nvPr/>
-        </p:nvSpPr>
-        <p:spPr>
-          <a:xfrm>
-            <a:off x="4389120" y="4270248"/>
-            <a:ext cx="4023360" cy="256032"/>
-          </a:xfrm>
-          <a:prstGeom prst="rect">
-            <a:avLst/>
-          </a:prstGeom>
-          <a:noFill/>
-        </p:spPr>
-        <p:txBody>
-          <a:bodyPr wrap="square">
-            <a:spAutoFit/>
-          </a:bodyPr>
-          <a:lstStyle/>
-          <a:p>
-            <a:pPr algn="ctr"/>
-            <a:r>
-              <a:rPr sz="950" b="0" i="0">
-                <a:solidFill>
-                  <a:srgbClr val="E8722A"/>
-                </a:solidFill>
-              </a:rPr>
-              <a:t>RADIUS Access-Request (CHAP)</a:t>
-            </a:r>
-          </a:p>
-        </p:txBody>
-      </p:sp>
-      <p:sp>
-        <p:nvSpPr>
-          <p:cNvPr id="54" name="Rectangle 53"/>
-          <p:cNvSpPr/>
-          <p:nvPr/>
-        </p:nvSpPr>
-        <p:spPr>
-          <a:xfrm>
-            <a:off x="7498080" y="4828032"/>
-            <a:ext cx="292608" cy="237744"/>
-          </a:xfrm>
-          <a:prstGeom prst="rect">
-            <a:avLst/>
-          </a:prstGeom>
-          <a:solidFill>
-            <a:srgbClr val="E8722A"/>
-          </a:solidFill>
-          <a:ln>
-            <a:noFill/>
-          </a:ln>
-        </p:spPr>
-        <p:style>
-          <a:lnRef idx="1">
-            <a:schemeClr val="accent1"/>
-          </a:lnRef>
-          <a:fillRef idx="3">
-            <a:schemeClr val="accent1"/>
-          </a:fillRef>
-          <a:effectRef idx="2">
-            <a:schemeClr val="accent1"/>
-          </a:effectRef>
-          <a:fontRef idx="minor">
-            <a:schemeClr val="lt1"/>
-          </a:fontRef>
-        </p:style>
-        <p:txBody>
-          <a:bodyPr rtlCol="0" anchor="ctr"/>
-          <a:lstStyle/>
-          <a:p>
-            <a:pPr algn="ctr"/>
-          </a:p>
-        </p:txBody>
-      </p:sp>
-      <p:sp>
-        <p:nvSpPr>
-          <p:cNvPr id="55" name="TextBox 54"/>
-          <p:cNvSpPr txBox="1"/>
-          <p:nvPr/>
-        </p:nvSpPr>
-        <p:spPr>
-          <a:xfrm>
-            <a:off x="7498080" y="4828032"/>
-            <a:ext cx="292608" cy="237744"/>
-          </a:xfrm>
-          <a:prstGeom prst="rect">
-            <a:avLst/>
-          </a:prstGeom>
-          <a:noFill/>
-        </p:spPr>
-        <p:txBody>
-          <a:bodyPr wrap="square">
-            <a:spAutoFit/>
-          </a:bodyPr>
-          <a:lstStyle/>
-          <a:p>
-            <a:pPr algn="ctr"/>
-            <a:r>
-              <a:rPr sz="1000" b="1" i="0">
-                <a:solidFill>
-                  <a:srgbClr val="FFFFFF"/>
-                </a:solidFill>
-              </a:rPr>
-              <a:t>9</a:t>
-            </a:r>
-          </a:p>
-        </p:txBody>
-      </p:sp>
-      <p:cxnSp>
-        <p:nvCxnSpPr>
-          <p:cNvPr id="56" name="Connector 55"/>
-          <p:cNvCxnSpPr/>
-          <p:nvPr/>
-        </p:nvCxnSpPr>
-        <p:spPr>
-          <a:xfrm>
-            <a:off x="7863840" y="4946904"/>
-            <a:ext cx="2743200" cy="0"/>
-          </a:xfrm>
-          <a:prstGeom prst="line">
-            <a:avLst/>
-          </a:prstGeom>
-          <a:ln w="20320">
-            <a:solidFill>
-              <a:srgbClr val="E8722A"/>
-            </a:solidFill>
-            <a:tailEnd type="triangle" w="med" len="med"/>
-          </a:ln>
-        </p:spPr>
-        <p:style>
-          <a:lnRef idx="2">
-            <a:schemeClr val="accent1"/>
-          </a:lnRef>
-          <a:fillRef idx="0">
-            <a:schemeClr val="accent1"/>
-          </a:fillRef>
-          <a:effectRef idx="1">
-            <a:schemeClr val="accent1"/>
-          </a:effectRef>
-          <a:fontRef idx="minor">
-            <a:schemeClr val="tx1"/>
-          </a:fontRef>
-        </p:style>
-      </p:cxnSp>
-      <p:sp>
-        <p:nvSpPr>
-          <p:cNvPr id="57" name="TextBox 56"/>
-          <p:cNvSpPr txBox="1"/>
-          <p:nvPr/>
-        </p:nvSpPr>
-        <p:spPr>
-          <a:xfrm>
-            <a:off x="7223760" y="4654296"/>
-            <a:ext cx="4023360" cy="256032"/>
-          </a:xfrm>
-          <a:prstGeom prst="rect">
-            <a:avLst/>
-          </a:prstGeom>
-          <a:noFill/>
-        </p:spPr>
-        <p:txBody>
-          <a:bodyPr wrap="square">
-            <a:spAutoFit/>
-          </a:bodyPr>
-          <a:lstStyle/>
-          <a:p>
-            <a:pPr algn="ctr"/>
-            <a:r>
-              <a:rPr sz="950" b="0" i="0">
-                <a:solidFill>
-                  <a:srgbClr val="E8722A"/>
-                </a:solidFill>
-              </a:rPr>
-              <a:t>SELECT radcheck/radreply WHERE user=</a:t>
-            </a:r>
-          </a:p>
-        </p:txBody>
-      </p:sp>
-      <p:sp>
-        <p:nvSpPr>
-          <p:cNvPr id="58" name="Rectangle 57"/>
-          <p:cNvSpPr/>
-          <p:nvPr/>
-        </p:nvSpPr>
-        <p:spPr>
-          <a:xfrm>
-            <a:off x="7498080" y="5212080"/>
-            <a:ext cx="292608" cy="237744"/>
-          </a:xfrm>
-          <a:prstGeom prst="rect">
-            <a:avLst/>
-          </a:prstGeom>
-          <a:solidFill>
-            <a:srgbClr val="E8722A"/>
-          </a:solidFill>
-          <a:ln>
-            <a:noFill/>
-          </a:ln>
-        </p:spPr>
-        <p:style>
-          <a:lnRef idx="1">
-            <a:schemeClr val="accent1"/>
-          </a:lnRef>
-          <a:fillRef idx="3">
-            <a:schemeClr val="accent1"/>
-          </a:fillRef>
-          <a:effectRef idx="2">
-            <a:schemeClr val="accent1"/>
-          </a:effectRef>
-          <a:fontRef idx="minor">
-            <a:schemeClr val="lt1"/>
-          </a:fontRef>
-        </p:style>
-        <p:txBody>
-          <a:bodyPr rtlCol="0" anchor="ctr"/>
-          <a:lstStyle/>
-          <a:p>
-            <a:pPr algn="ctr"/>
-          </a:p>
-        </p:txBody>
-      </p:sp>
-      <p:sp>
-        <p:nvSpPr>
-          <p:cNvPr id="59" name="TextBox 58"/>
-          <p:cNvSpPr txBox="1"/>
-          <p:nvPr/>
-        </p:nvSpPr>
-        <p:spPr>
-          <a:xfrm>
-            <a:off x="7498080" y="5212080"/>
-            <a:ext cx="292608" cy="237744"/>
-          </a:xfrm>
-          <a:prstGeom prst="rect">
-            <a:avLst/>
-          </a:prstGeom>
-          <a:noFill/>
-        </p:spPr>
-        <p:txBody>
-          <a:bodyPr wrap="square">
-            <a:spAutoFit/>
-          </a:bodyPr>
-          <a:lstStyle/>
-          <a:p>
-            <a:pPr algn="ctr"/>
-            <a:r>
-              <a:rPr sz="1000" b="1" i="0">
-                <a:solidFill>
-                  <a:srgbClr val="FFFFFF"/>
-                </a:solidFill>
-              </a:rPr>
-              <a:t>10</a:t>
-            </a:r>
-          </a:p>
-        </p:txBody>
-      </p:sp>
-      <p:cxnSp>
-        <p:nvCxnSpPr>
-          <p:cNvPr id="60" name="Connector 59"/>
-          <p:cNvCxnSpPr/>
-          <p:nvPr/>
-        </p:nvCxnSpPr>
-        <p:spPr>
-          <a:xfrm flipH="1">
-            <a:off x="7863840" y="5330952"/>
-            <a:ext cx="2743200" cy="0"/>
-          </a:xfrm>
-          <a:prstGeom prst="line">
-            <a:avLst/>
-          </a:prstGeom>
-          <a:ln w="20320">
-            <a:solidFill>
-              <a:srgbClr val="E8722A"/>
-            </a:solidFill>
-            <a:prstDash val="dash"/>
-            <a:tailEnd type="triangle" w="med" len="med"/>
-          </a:ln>
-        </p:spPr>
-        <p:style>
-          <a:lnRef idx="2">
-            <a:schemeClr val="accent1"/>
-          </a:lnRef>
-          <a:fillRef idx="0">
-            <a:schemeClr val="accent1"/>
-          </a:fillRef>
-          <a:effectRef idx="1">
-            <a:schemeClr val="accent1"/>
-          </a:effectRef>
-          <a:fontRef idx="minor">
-            <a:schemeClr val="tx1"/>
-          </a:fontRef>
-        </p:style>
-      </p:cxnSp>
-      <p:sp>
-        <p:nvSpPr>
-          <p:cNvPr id="61" name="TextBox 60"/>
-          <p:cNvSpPr txBox="1"/>
-          <p:nvPr/>
-        </p:nvSpPr>
-        <p:spPr>
-          <a:xfrm>
-            <a:off x="7223760" y="5038344"/>
-            <a:ext cx="4023360" cy="256032"/>
-          </a:xfrm>
-          <a:prstGeom prst="rect">
-            <a:avLst/>
-          </a:prstGeom>
-          <a:noFill/>
-        </p:spPr>
-        <p:txBody>
-          <a:bodyPr wrap="square">
-            <a:spAutoFit/>
-          </a:bodyPr>
-          <a:lstStyle/>
-          <a:p>
-            <a:pPr algn="ctr"/>
-            <a:r>
-              <a:rPr sz="950" b="0" i="0">
-                <a:solidFill>
-                  <a:srgbClr val="E8722A"/>
-                </a:solidFill>
-              </a:rPr>
-              <a:t>rows (Cleartext-Password + WISPr attrs)</a:t>
-            </a:r>
-          </a:p>
-        </p:txBody>
-      </p:sp>
-      <p:sp>
-        <p:nvSpPr>
-          <p:cNvPr id="62" name="Rectangle 61"/>
-          <p:cNvSpPr/>
-          <p:nvPr/>
-        </p:nvSpPr>
-        <p:spPr>
-          <a:xfrm>
-            <a:off x="4572000" y="5596128"/>
-            <a:ext cx="292608" cy="237744"/>
-          </a:xfrm>
-          <a:prstGeom prst="rect">
-            <a:avLst/>
-          </a:prstGeom>
-          <a:solidFill>
-            <a:srgbClr val="27AE60"/>
-          </a:solidFill>
-          <a:ln>
-            <a:noFill/>
-          </a:ln>
-        </p:spPr>
-        <p:style>
-          <a:lnRef idx="1">
-            <a:schemeClr val="accent1"/>
-          </a:lnRef>
-          <a:fillRef idx="3">
-            <a:schemeClr val="accent1"/>
-          </a:fillRef>
-          <a:effectRef idx="2">
-            <a:schemeClr val="accent1"/>
-          </a:effectRef>
-          <a:fontRef idx="minor">
-            <a:schemeClr val="lt1"/>
-          </a:fontRef>
-        </p:style>
-        <p:txBody>
-          <a:bodyPr rtlCol="0" anchor="ctr"/>
-          <a:lstStyle/>
-          <a:p>
-            <a:pPr algn="ctr"/>
-          </a:p>
-        </p:txBody>
-      </p:sp>
-      <p:sp>
-        <p:nvSpPr>
-          <p:cNvPr id="63" name="TextBox 62"/>
-          <p:cNvSpPr txBox="1"/>
-          <p:nvPr/>
-        </p:nvSpPr>
-        <p:spPr>
-          <a:xfrm>
-            <a:off x="4572000" y="5596128"/>
-            <a:ext cx="292608" cy="237744"/>
-          </a:xfrm>
-          <a:prstGeom prst="rect">
-            <a:avLst/>
-          </a:prstGeom>
-          <a:noFill/>
-        </p:spPr>
-        <p:txBody>
-          <a:bodyPr wrap="square">
-            <a:spAutoFit/>
-          </a:bodyPr>
-          <a:lstStyle/>
-          <a:p>
-            <a:pPr algn="ctr"/>
-            <a:r>
-              <a:rPr sz="1000" b="1" i="0">
-                <a:solidFill>
-                  <a:srgbClr val="FFFFFF"/>
-                </a:solidFill>
-              </a:rPr>
-              <a:t>11</a:t>
-            </a:r>
-          </a:p>
-        </p:txBody>
-      </p:sp>
-      <p:cxnSp>
-        <p:nvCxnSpPr>
-          <p:cNvPr id="64" name="Connector 63"/>
-          <p:cNvCxnSpPr/>
-          <p:nvPr/>
-        </p:nvCxnSpPr>
-        <p:spPr>
-          <a:xfrm flipH="1">
-            <a:off x="4937760" y="5715000"/>
-            <a:ext cx="2926080" cy="0"/>
-          </a:xfrm>
-          <a:prstGeom prst="line">
-            <a:avLst/>
-          </a:prstGeom>
-          <a:ln w="20320">
-            <a:solidFill>
-              <a:srgbClr val="27AE60"/>
-            </a:solidFill>
-            <a:prstDash val="dash"/>
-            <a:tailEnd type="triangle" w="med" len="med"/>
-          </a:ln>
-        </p:spPr>
-        <p:style>
-          <a:lnRef idx="2">
-            <a:schemeClr val="accent1"/>
-          </a:lnRef>
-          <a:fillRef idx="0">
-            <a:schemeClr val="accent1"/>
-          </a:fillRef>
-          <a:effectRef idx="1">
-            <a:schemeClr val="accent1"/>
-          </a:effectRef>
-          <a:fontRef idx="minor">
-            <a:schemeClr val="tx1"/>
-          </a:fontRef>
-        </p:style>
-      </p:cxnSp>
-      <p:sp>
-        <p:nvSpPr>
-          <p:cNvPr id="65" name="TextBox 64"/>
-          <p:cNvSpPr txBox="1"/>
-          <p:nvPr/>
-        </p:nvSpPr>
-        <p:spPr>
-          <a:xfrm>
-            <a:off x="4389120" y="5422392"/>
-            <a:ext cx="4023360" cy="256032"/>
-          </a:xfrm>
-          <a:prstGeom prst="rect">
-            <a:avLst/>
-          </a:prstGeom>
-          <a:noFill/>
-        </p:spPr>
-        <p:txBody>
-          <a:bodyPr wrap="square">
-            <a:spAutoFit/>
-          </a:bodyPr>
-          <a:lstStyle/>
-          <a:p>
-            <a:pPr algn="ctr"/>
-            <a:r>
-              <a:rPr sz="950" b="0" i="0">
-                <a:solidFill>
                   <a:srgbClr val="27AE60"/>
                 </a:solidFill>
               </a:rPr>
-              <a:t>Access-Accept (WISPr-Bandwidth 等)</a:t>
-            </a:r>
-          </a:p>
-        </p:txBody>
-      </p:sp>
-      <p:sp>
-        <p:nvSpPr>
-          <p:cNvPr id="66" name="Rectangle 65"/>
-          <p:cNvSpPr/>
-          <p:nvPr/>
-        </p:nvSpPr>
-        <p:spPr>
-          <a:xfrm>
-            <a:off x="4572000" y="5980176"/>
-            <a:ext cx="292608" cy="237744"/>
-          </a:xfrm>
-          <a:prstGeom prst="rect">
-            <a:avLst/>
-          </a:prstGeom>
-          <a:solidFill>
-            <a:srgbClr val="E8722A"/>
-          </a:solidFill>
-          <a:ln>
-            <a:noFill/>
-          </a:ln>
-        </p:spPr>
-        <p:style>
-          <a:lnRef idx="1">
-            <a:schemeClr val="accent1"/>
-          </a:lnRef>
-          <a:fillRef idx="3">
-            <a:schemeClr val="accent1"/>
-          </a:fillRef>
-          <a:effectRef idx="2">
-            <a:schemeClr val="accent1"/>
-          </a:effectRef>
-          <a:fontRef idx="minor">
-            <a:schemeClr val="lt1"/>
-          </a:fontRef>
-        </p:style>
-        <p:txBody>
-          <a:bodyPr rtlCol="0" anchor="ctr"/>
-          <a:lstStyle/>
-          <a:p>
-            <a:pPr algn="ctr"/>
-          </a:p>
-        </p:txBody>
-      </p:sp>
-      <p:sp>
-        <p:nvSpPr>
-          <p:cNvPr id="67" name="TextBox 66"/>
-          <p:cNvSpPr txBox="1"/>
-          <p:nvPr/>
-        </p:nvSpPr>
-        <p:spPr>
-          <a:xfrm>
-            <a:off x="4572000" y="5980176"/>
-            <a:ext cx="292608" cy="237744"/>
-          </a:xfrm>
-          <a:prstGeom prst="rect">
-            <a:avLst/>
-          </a:prstGeom>
-          <a:noFill/>
-        </p:spPr>
-        <p:txBody>
-          <a:bodyPr wrap="square">
-            <a:spAutoFit/>
-          </a:bodyPr>
-          <a:lstStyle/>
-          <a:p>
-            <a:pPr algn="ctr"/>
-            <a:r>
-              <a:rPr sz="1000" b="1" i="0">
-                <a:solidFill>
-                  <a:srgbClr val="FFFFFF"/>
-                </a:solidFill>
-              </a:rPr>
-              <a:t>12</a:t>
-            </a:r>
-          </a:p>
-        </p:txBody>
-      </p:sp>
-      <p:cxnSp>
-        <p:nvCxnSpPr>
-          <p:cNvPr id="68" name="Connector 67"/>
-          <p:cNvCxnSpPr/>
-          <p:nvPr/>
-        </p:nvCxnSpPr>
-        <p:spPr>
-          <a:xfrm>
-            <a:off x="4937760" y="6099048"/>
-            <a:ext cx="2926080" cy="0"/>
-          </a:xfrm>
-          <a:prstGeom prst="line">
-            <a:avLst/>
-          </a:prstGeom>
-          <a:ln w="20320">
-            <a:solidFill>
-              <a:srgbClr val="E8722A"/>
-            </a:solidFill>
-            <a:tailEnd type="triangle" w="med" len="med"/>
-          </a:ln>
-        </p:spPr>
-        <p:style>
-          <a:lnRef idx="2">
-            <a:schemeClr val="accent1"/>
-          </a:lnRef>
-          <a:fillRef idx="0">
-            <a:schemeClr val="accent1"/>
-          </a:fillRef>
-          <a:effectRef idx="1">
-            <a:schemeClr val="accent1"/>
-          </a:effectRef>
-          <a:fontRef idx="minor">
-            <a:schemeClr val="tx1"/>
-          </a:fontRef>
-        </p:style>
-      </p:cxnSp>
-      <p:sp>
-        <p:nvSpPr>
-          <p:cNvPr id="69" name="TextBox 68"/>
-          <p:cNvSpPr txBox="1"/>
-          <p:nvPr/>
-        </p:nvSpPr>
-        <p:spPr>
-          <a:xfrm>
-            <a:off x="4389120" y="5806440"/>
-            <a:ext cx="4023360" cy="256032"/>
-          </a:xfrm>
-          <a:prstGeom prst="rect">
-            <a:avLst/>
-          </a:prstGeom>
-          <a:noFill/>
-        </p:spPr>
-        <p:txBody>
-          <a:bodyPr wrap="square">
-            <a:spAutoFit/>
-          </a:bodyPr>
-          <a:lstStyle/>
-          <a:p>
-            <a:pPr algn="ctr"/>
-            <a:r>
-              <a:rPr sz="950" b="0" i="0">
-                <a:solidFill>
-                  <a:srgbClr val="E8722A"/>
-                </a:solidFill>
-              </a:rPr>
-              <a:t>Accounting-Request Start</a:t>
-            </a:r>
-          </a:p>
-        </p:txBody>
-      </p:sp>
-      <p:sp>
-        <p:nvSpPr>
-          <p:cNvPr id="70" name="Rectangle 69"/>
-          <p:cNvSpPr/>
-          <p:nvPr/>
-        </p:nvSpPr>
-        <p:spPr>
-          <a:xfrm>
-            <a:off x="548640" y="6364224"/>
-            <a:ext cx="292608" cy="237744"/>
-          </a:xfrm>
-          <a:prstGeom prst="rect">
-            <a:avLst/>
-          </a:prstGeom>
-          <a:solidFill>
-            <a:srgbClr val="27AE60"/>
-          </a:solidFill>
-          <a:ln>
-            <a:noFill/>
-          </a:ln>
-        </p:spPr>
-        <p:style>
-          <a:lnRef idx="1">
-            <a:schemeClr val="accent1"/>
-          </a:lnRef>
-          <a:fillRef idx="3">
-            <a:schemeClr val="accent1"/>
-          </a:fillRef>
-          <a:effectRef idx="2">
-            <a:schemeClr val="accent1"/>
-          </a:effectRef>
-          <a:fontRef idx="minor">
-            <a:schemeClr val="lt1"/>
-          </a:fontRef>
-        </p:style>
-        <p:txBody>
-          <a:bodyPr rtlCol="0" anchor="ctr"/>
-          <a:lstStyle/>
-          <a:p>
-            <a:pPr algn="ctr"/>
-          </a:p>
-        </p:txBody>
-      </p:sp>
-      <p:sp>
-        <p:nvSpPr>
-          <p:cNvPr id="71" name="TextBox 70"/>
-          <p:cNvSpPr txBox="1"/>
-          <p:nvPr/>
-        </p:nvSpPr>
-        <p:spPr>
-          <a:xfrm>
-            <a:off x="548640" y="6364224"/>
-            <a:ext cx="292608" cy="237744"/>
-          </a:xfrm>
-          <a:prstGeom prst="rect">
-            <a:avLst/>
-          </a:prstGeom>
-          <a:noFill/>
-        </p:spPr>
-        <p:txBody>
-          <a:bodyPr wrap="square">
-            <a:spAutoFit/>
-          </a:bodyPr>
-          <a:lstStyle/>
-          <a:p>
-            <a:pPr algn="ctr"/>
-            <a:r>
-              <a:rPr sz="1000" b="1" i="0">
-                <a:solidFill>
-                  <a:srgbClr val="FFFFFF"/>
-                </a:solidFill>
-              </a:rPr>
-              <a:t>13</a:t>
-            </a:r>
-          </a:p>
-        </p:txBody>
-      </p:sp>
-      <p:cxnSp>
-        <p:nvCxnSpPr>
-          <p:cNvPr id="72" name="Connector 71"/>
-          <p:cNvCxnSpPr/>
-          <p:nvPr/>
-        </p:nvCxnSpPr>
-        <p:spPr>
-          <a:xfrm flipH="1">
-            <a:off x="914400" y="6483096"/>
-            <a:ext cx="4023360" cy="0"/>
-          </a:xfrm>
-          <a:prstGeom prst="line">
-            <a:avLst/>
-          </a:prstGeom>
-          <a:ln w="20320">
-            <a:solidFill>
-              <a:srgbClr val="27AE60"/>
-            </a:solidFill>
-            <a:prstDash val="dash"/>
-            <a:tailEnd type="triangle" w="med" len="med"/>
-          </a:ln>
-        </p:spPr>
-        <p:style>
-          <a:lnRef idx="2">
-            <a:schemeClr val="accent1"/>
-          </a:lnRef>
-          <a:fillRef idx="0">
-            <a:schemeClr val="accent1"/>
-          </a:fillRef>
-          <a:effectRef idx="1">
-            <a:schemeClr val="accent1"/>
-          </a:effectRef>
-          <a:fontRef idx="minor">
-            <a:schemeClr val="tx1"/>
-          </a:fontRef>
-        </p:style>
-      </p:cxnSp>
-      <p:sp>
-        <p:nvSpPr>
-          <p:cNvPr id="73" name="TextBox 72"/>
-          <p:cNvSpPr txBox="1"/>
-          <p:nvPr/>
-        </p:nvSpPr>
-        <p:spPr>
-          <a:xfrm>
-            <a:off x="914400" y="6190488"/>
-            <a:ext cx="4023360" cy="256032"/>
-          </a:xfrm>
-          <a:prstGeom prst="rect">
-            <a:avLst/>
-          </a:prstGeom>
-          <a:noFill/>
-        </p:spPr>
-        <p:txBody>
-          <a:bodyPr wrap="square">
-            <a:spAutoFit/>
-          </a:bodyPr>
-          <a:lstStyle/>
-          <a:p>
-            <a:pPr algn="ctr"/>
-            <a:r>
-              <a:rPr sz="950" b="0" i="0">
-                <a:solidFill>
-                  <a:srgbClr val="27AE60"/>
-                </a:solidFill>
-              </a:rPr>
-              <a:t>授權 ACL 開通 + 302 → google.com</a:t>
-            </a:r>
-          </a:p>
-        </p:txBody>
-      </p:sp>
-      <p:sp>
-        <p:nvSpPr>
-          <p:cNvPr id="74" name="Rectangle 73"/>
+              <a:t>授權 ACL + leaky bucket 限速 + 302 google.com</a:t>
+            </a:r>
+          </a:p>
+        </p:txBody>
+      </p:sp>
+      <p:sp>
+        <p:nvSpPr>
+          <p:cNvPr id="49" name="Rectangle 48"/>
           <p:cNvSpPr/>
           <p:nvPr/>
         </p:nvSpPr>
@@ -22341,7 +21408,7 @@
       </p:sp>
       <p:sp>
         <p:nvSpPr>
-          <p:cNvPr id="75" name="TextBox 74"/>
+          <p:cNvPr id="50" name="TextBox 49"/>
           <p:cNvSpPr txBox="1"/>
           <p:nvPr/>
         </p:nvSpPr>
@@ -22361,14 +21428,14 @@
           </a:bodyPr>
           <a:lstStyle/>
           <a:p>
-            <a:pPr algn="l"/>
+            <a:pPr algn="ctr"/>
             <a:r>
               <a:rPr sz="1000" b="0" i="0">
                 <a:solidFill>
                   <a:srgbClr val="333333"/>
                 </a:solidFill>
               </a:rPr>
-              <a:t>▸ 步驟 8-12 走 RADIUS UDP；CHAP 在 chilli↔RADIUS 之間驗算   ▸ 步驟 13 後：interim acct 每 300s + 條件式 CoA 踢人</a:t>
+              <a:t>─── = Request  ┄┄ = Response   |   ④⑤ 走 RADIUS UDP 1812/1813   |   ⑥ 後：interim acct 每 300s</a:t>
             </a:r>
           </a:p>
         </p:txBody>

</xml_diff>